<commit_message>
Cite Sony audited 20-F for P0-08 revenue
</commit_message>
<xml_diff>
--- a/docs/product/ppt-benchmark-materials/PPT-P0-08/p0-08-reference.pptx
+++ b/docs/product/ppt-benchmark-materials/PPT-P0-08/p0-08-reference.pptx
@@ -1331,7 +1331,7 @@
               <a:rPr lang="en-US" dirty="0"/>
               <a:t>Sony：原币销售及金融服务收入
 候选参考稿；Sony 官方 PDF 尚待下载，本稿未经财务审阅和 PowerPoint 宿主验收。
-[sony-sales] https://www.sony.com/en/SonyInfo/IR/library/presen/er/pdf/23q4_sony.pdf · PDF 第 4 页
+[sony-sales] https://www.sony.com/en/SonyInfo/IR/library/FY2023_20F_PDF.pdf · PDF 第 48 页
 Sony 销售及金融服务收入 13020768 百万日元
 Attribution supplied by the input; source accuracy and license rights have not been independently verified.</a:t>
             </a:r>
@@ -2699,7 +2699,7 @@
                 <a:ea typeface="Noto Sans CJK SC" pitchFamily="34" charset="-122"/>
                 <a:cs typeface="Noto Sans CJK SC" pitchFamily="34" charset="-120"/>
               </a:rPr>
-              <a:t>13,020,768 百万日元；Sony 官方年度财务报表，PDF 第 4 页。包括金融服务收入。</a:t>
+              <a:t>13,020,768 百万日元；Sony Form 20-F，PDF 第 48 页。包括金融服务收入。</a:t>
             </a:r>
             <a:endParaRPr lang="en-US" sz="1800" dirty="0"/>
           </a:p>
@@ -2754,7 +2754,7 @@
                 <a:ea typeface="Noto Sans CJK SC" pitchFamily="34" charset="-122"/>
                 <a:cs typeface="Noto Sans CJK SC" pitchFamily="34" charset="-120"/>
               </a:rPr>
-              <a:t>来源：Sony FY2023 官方财务报表，PDF 第 4 页；原件待冻结</a:t>
+              <a:t>来源：Sony FY2023 Form 20-F，PDF 第 48 页；原件待冻结</a:t>
             </a:r>
             <a:endParaRPr lang="en-US" sz="900" dirty="0"/>
           </a:p>
@@ -2793,7 +2793,7 @@
                 <a:ea typeface="Noto Sans CJK SC" pitchFamily="34" charset="-122"/>
                 <a:cs typeface="Noto Sans CJK SC" pitchFamily="34" charset="-120"/>
               </a:rPr>
-              <a:t>[sony-sales] https://www.sony.com/en/SonyInfo/IR/library/presen/er/pdf/23q4_sony.pdf · PDF 第 4 页</a:t>
+              <a:t>[sony-sales] https://www.sony.com/en/SonyInfo/IR/library/FY2023_20F_PDF.pdf · PDF 第 48 页</a:t>
             </a:r>
             <a:endParaRPr lang="en-US" sz="800" dirty="0"/>
           </a:p>

</xml_diff>

<commit_message>
Add native comparability and blank-result matrices
</commit_message>
<xml_diff>
--- a/docs/product/ppt-benchmark-materials/PPT-P0-08/p0-08-reference.pptx
+++ b/docs/product/ppt-benchmark-materials/PPT-P0-08/p0-08-reference.pptx
@@ -2322,7 +2322,7 @@
         <p:spPr>
           <a:xfrm>
             <a:off x="822960" y="1463040"/>
-            <a:ext cx="10424160" cy="3200400"/>
+            <a:ext cx="10424160" cy="731520"/>
           </a:xfrm>
           <a:prstGeom prst="rect">
             <a:avLst/>
@@ -2352,9 +2352,1025 @@
           </a:p>
         </p:txBody>
       </p:sp>
-      <p:sp>
-        <p:nvSpPr>
-          <p:cNvPr id="4" name="footer"/>
+      <p:graphicFrame>
+        <p:nvGraphicFramePr>
+          <p:cNvPr id="4" name="basis-matrix"/>
+          <p:cNvGraphicFramePr>
+            <a:graphicFrameLocks noGrp="1"/>
+          </p:cNvGraphicFramePr>
+          <p:nvPr>
+            <p:extLst>
+              <p:ext uri="{D42A27DB-BD31-4B8C-83A1-F6EECF244321}">
+                <p14:modId xmlns:p14="http://schemas.microsoft.com/office/powerpoint/2010/main" val="1579011935"/>
+              </p:ext>
+            </p:extLst>
+          </p:nvPr>
+        </p:nvGraphicFramePr>
+        <p:xfrm>
+          <a:off x="822960" y="2423160"/>
+          <a:ext cx="10424160" cy="3017520"/>
+        </p:xfrm>
+        <a:graphic>
+          <a:graphicData uri="http://schemas.openxmlformats.org/drawingml/2006/table">
+            <a:tbl>
+              <a:tblPr/>
+              <a:tblGrid>
+                <a:gridCol w="3474720"/>
+                <a:gridCol w="3474720"/>
+                <a:gridCol w="3474720"/>
+              </a:tblGrid>
+              <a:tr h="603504">
+                <a:tc>
+                  <a:txBody>
+                    <a:bodyPr/>
+                    <a:lstStyle/>
+                    <a:p>
+                      <a:pPr indent="0" marL="0">
+                        <a:buNone/>
+                      </a:pPr>
+                      <a:r>
+                        <a:rPr lang="en-US" sz="1500" dirty="0">
+                          <a:solidFill>
+                            <a:srgbClr val="173248"/>
+                          </a:solidFill>
+                          <a:latin typeface="Noto Sans CJK SC" pitchFamily="34" charset="0"/>
+                          <a:ea typeface="Noto Sans CJK SC" pitchFamily="34" charset="-122"/>
+                          <a:cs typeface="Noto Sans CJK SC" pitchFamily="34" charset="-120"/>
+                        </a:rPr>
+                        <a:t>核对项</a:t>
+                      </a:r>
+                      <a:endParaRPr lang="en-US" sz="1500" dirty="0">
+                        <a:latin typeface="Noto Sans CJK SC" charset="0"/>
+                        <a:ea typeface="Noto Sans CJK SC" charset="0"/>
+                        <a:cs typeface="Noto Sans CJK SC" charset="0"/>
+                      </a:endParaRPr>
+                    </a:p>
+                  </a:txBody>
+                  <a:tcPr marL="36576" marR="36576" marT="36576" marB="36576">
+                    <a:lnL w="12700" cap="flat" cmpd="sng" algn="ctr">
+                      <a:solidFill>
+                        <a:srgbClr val="087D83"/>
+                      </a:solidFill>
+                      <a:prstDash val="solid"/>
+                      <a:round/>
+                      <a:headEnd type="none" w="med" len="med"/>
+                      <a:tailEnd type="none" w="med" len="med"/>
+                    </a:lnL>
+                    <a:lnR w="12700" cap="flat" cmpd="sng" algn="ctr">
+                      <a:solidFill>
+                        <a:srgbClr val="087D83"/>
+                      </a:solidFill>
+                      <a:prstDash val="solid"/>
+                      <a:round/>
+                      <a:headEnd type="none" w="med" len="med"/>
+                      <a:tailEnd type="none" w="med" len="med"/>
+                    </a:lnR>
+                    <a:lnT w="12700" cap="flat" cmpd="sng" algn="ctr">
+                      <a:solidFill>
+                        <a:srgbClr val="087D83"/>
+                      </a:solidFill>
+                      <a:prstDash val="solid"/>
+                      <a:round/>
+                      <a:headEnd type="none" w="med" len="med"/>
+                      <a:tailEnd type="none" w="med" len="med"/>
+                    </a:lnT>
+                    <a:lnB w="12700" cap="flat" cmpd="sng" algn="ctr">
+                      <a:solidFill>
+                        <a:srgbClr val="087D83"/>
+                      </a:solidFill>
+                      <a:prstDash val="solid"/>
+                      <a:round/>
+                      <a:headEnd type="none" w="med" len="med"/>
+                      <a:tailEnd type="none" w="med" len="med"/>
+                    </a:lnB>
+                  </a:tcPr>
+                </a:tc>
+                <a:tc>
+                  <a:txBody>
+                    <a:bodyPr/>
+                    <a:lstStyle/>
+                    <a:p>
+                      <a:pPr indent="0" marL="0">
+                        <a:buNone/>
+                      </a:pPr>
+                      <a:r>
+                        <a:rPr lang="en-US" sz="1500" dirty="0">
+                          <a:solidFill>
+                            <a:srgbClr val="173248"/>
+                          </a:solidFill>
+                          <a:latin typeface="Noto Sans CJK SC" pitchFamily="34" charset="0"/>
+                          <a:ea typeface="Noto Sans CJK SC" pitchFamily="34" charset="-122"/>
+                          <a:cs typeface="Noto Sans CJK SC" pitchFamily="34" charset="-120"/>
+                        </a:rPr>
+                        <a:t>Apple FY2024</a:t>
+                      </a:r>
+                      <a:endParaRPr lang="en-US" sz="1500" dirty="0">
+                        <a:latin typeface="Noto Sans CJK SC" charset="0"/>
+                        <a:ea typeface="Noto Sans CJK SC" charset="0"/>
+                        <a:cs typeface="Noto Sans CJK SC" charset="0"/>
+                      </a:endParaRPr>
+                    </a:p>
+                  </a:txBody>
+                  <a:tcPr marL="36576" marR="36576" marT="36576" marB="36576">
+                    <a:lnL w="12700" cap="flat" cmpd="sng" algn="ctr">
+                      <a:solidFill>
+                        <a:srgbClr val="087D83"/>
+                      </a:solidFill>
+                      <a:prstDash val="solid"/>
+                      <a:round/>
+                      <a:headEnd type="none" w="med" len="med"/>
+                      <a:tailEnd type="none" w="med" len="med"/>
+                    </a:lnL>
+                    <a:lnR w="12700" cap="flat" cmpd="sng" algn="ctr">
+                      <a:solidFill>
+                        <a:srgbClr val="087D83"/>
+                      </a:solidFill>
+                      <a:prstDash val="solid"/>
+                      <a:round/>
+                      <a:headEnd type="none" w="med" len="med"/>
+                      <a:tailEnd type="none" w="med" len="med"/>
+                    </a:lnR>
+                    <a:lnT w="12700" cap="flat" cmpd="sng" algn="ctr">
+                      <a:solidFill>
+                        <a:srgbClr val="087D83"/>
+                      </a:solidFill>
+                      <a:prstDash val="solid"/>
+                      <a:round/>
+                      <a:headEnd type="none" w="med" len="med"/>
+                      <a:tailEnd type="none" w="med" len="med"/>
+                    </a:lnT>
+                    <a:lnB w="12700" cap="flat" cmpd="sng" algn="ctr">
+                      <a:solidFill>
+                        <a:srgbClr val="087D83"/>
+                      </a:solidFill>
+                      <a:prstDash val="solid"/>
+                      <a:round/>
+                      <a:headEnd type="none" w="med" len="med"/>
+                      <a:tailEnd type="none" w="med" len="med"/>
+                    </a:lnB>
+                  </a:tcPr>
+                </a:tc>
+                <a:tc>
+                  <a:txBody>
+                    <a:bodyPr/>
+                    <a:lstStyle/>
+                    <a:p>
+                      <a:pPr indent="0" marL="0">
+                        <a:buNone/>
+                      </a:pPr>
+                      <a:r>
+                        <a:rPr lang="en-US" sz="1500" dirty="0">
+                          <a:solidFill>
+                            <a:srgbClr val="173248"/>
+                          </a:solidFill>
+                          <a:latin typeface="Noto Sans CJK SC" pitchFamily="34" charset="0"/>
+                          <a:ea typeface="Noto Sans CJK SC" pitchFamily="34" charset="-122"/>
+                          <a:cs typeface="Noto Sans CJK SC" pitchFamily="34" charset="-120"/>
+                        </a:rPr>
+                        <a:t>Sony FY2023</a:t>
+                      </a:r>
+                      <a:endParaRPr lang="en-US" sz="1500" dirty="0">
+                        <a:latin typeface="Noto Sans CJK SC" charset="0"/>
+                        <a:ea typeface="Noto Sans CJK SC" charset="0"/>
+                        <a:cs typeface="Noto Sans CJK SC" charset="0"/>
+                      </a:endParaRPr>
+                    </a:p>
+                  </a:txBody>
+                  <a:tcPr marL="36576" marR="36576" marT="36576" marB="36576">
+                    <a:lnL w="12700" cap="flat" cmpd="sng" algn="ctr">
+                      <a:solidFill>
+                        <a:srgbClr val="087D83"/>
+                      </a:solidFill>
+                      <a:prstDash val="solid"/>
+                      <a:round/>
+                      <a:headEnd type="none" w="med" len="med"/>
+                      <a:tailEnd type="none" w="med" len="med"/>
+                    </a:lnL>
+                    <a:lnR w="12700" cap="flat" cmpd="sng" algn="ctr">
+                      <a:solidFill>
+                        <a:srgbClr val="087D83"/>
+                      </a:solidFill>
+                      <a:prstDash val="solid"/>
+                      <a:round/>
+                      <a:headEnd type="none" w="med" len="med"/>
+                      <a:tailEnd type="none" w="med" len="med"/>
+                    </a:lnR>
+                    <a:lnT w="12700" cap="flat" cmpd="sng" algn="ctr">
+                      <a:solidFill>
+                        <a:srgbClr val="087D83"/>
+                      </a:solidFill>
+                      <a:prstDash val="solid"/>
+                      <a:round/>
+                      <a:headEnd type="none" w="med" len="med"/>
+                      <a:tailEnd type="none" w="med" len="med"/>
+                    </a:lnT>
+                    <a:lnB w="12700" cap="flat" cmpd="sng" algn="ctr">
+                      <a:solidFill>
+                        <a:srgbClr val="087D83"/>
+                      </a:solidFill>
+                      <a:prstDash val="solid"/>
+                      <a:round/>
+                      <a:headEnd type="none" w="med" len="med"/>
+                      <a:tailEnd type="none" w="med" len="med"/>
+                    </a:lnB>
+                  </a:tcPr>
+                </a:tc>
+              </a:tr>
+              <a:tr h="603504">
+                <a:tc>
+                  <a:txBody>
+                    <a:bodyPr/>
+                    <a:lstStyle/>
+                    <a:p>
+                      <a:pPr indent="0" marL="0">
+                        <a:buNone/>
+                      </a:pPr>
+                      <a:r>
+                        <a:rPr lang="en-US" sz="1500" dirty="0">
+                          <a:solidFill>
+                            <a:srgbClr val="173248"/>
+                          </a:solidFill>
+                          <a:latin typeface="Noto Sans CJK SC" pitchFamily="34" charset="0"/>
+                          <a:ea typeface="Noto Sans CJK SC" pitchFamily="34" charset="-122"/>
+                          <a:cs typeface="Noto Sans CJK SC" pitchFamily="34" charset="-120"/>
+                        </a:rPr>
+                        <a:t>财年结束</a:t>
+                      </a:r>
+                      <a:endParaRPr lang="en-US" sz="1500" dirty="0">
+                        <a:latin typeface="Noto Sans CJK SC" charset="0"/>
+                        <a:ea typeface="Noto Sans CJK SC" charset="0"/>
+                        <a:cs typeface="Noto Sans CJK SC" charset="0"/>
+                      </a:endParaRPr>
+                    </a:p>
+                  </a:txBody>
+                  <a:tcPr marL="36576" marR="36576" marT="36576" marB="36576">
+                    <a:lnL w="12700" cap="flat" cmpd="sng" algn="ctr">
+                      <a:solidFill>
+                        <a:srgbClr val="087D83"/>
+                      </a:solidFill>
+                      <a:prstDash val="solid"/>
+                      <a:round/>
+                      <a:headEnd type="none" w="med" len="med"/>
+                      <a:tailEnd type="none" w="med" len="med"/>
+                    </a:lnL>
+                    <a:lnR w="12700" cap="flat" cmpd="sng" algn="ctr">
+                      <a:solidFill>
+                        <a:srgbClr val="087D83"/>
+                      </a:solidFill>
+                      <a:prstDash val="solid"/>
+                      <a:round/>
+                      <a:headEnd type="none" w="med" len="med"/>
+                      <a:tailEnd type="none" w="med" len="med"/>
+                    </a:lnR>
+                    <a:lnT w="12700" cap="flat" cmpd="sng" algn="ctr">
+                      <a:solidFill>
+                        <a:srgbClr val="087D83"/>
+                      </a:solidFill>
+                      <a:prstDash val="solid"/>
+                      <a:round/>
+                      <a:headEnd type="none" w="med" len="med"/>
+                      <a:tailEnd type="none" w="med" len="med"/>
+                    </a:lnT>
+                    <a:lnB w="12700" cap="flat" cmpd="sng" algn="ctr">
+                      <a:solidFill>
+                        <a:srgbClr val="087D83"/>
+                      </a:solidFill>
+                      <a:prstDash val="solid"/>
+                      <a:round/>
+                      <a:headEnd type="none" w="med" len="med"/>
+                      <a:tailEnd type="none" w="med" len="med"/>
+                    </a:lnB>
+                  </a:tcPr>
+                </a:tc>
+                <a:tc>
+                  <a:txBody>
+                    <a:bodyPr/>
+                    <a:lstStyle/>
+                    <a:p>
+                      <a:pPr indent="0" marL="0">
+                        <a:buNone/>
+                      </a:pPr>
+                      <a:r>
+                        <a:rPr lang="en-US" sz="1500" dirty="0">
+                          <a:solidFill>
+                            <a:srgbClr val="173248"/>
+                          </a:solidFill>
+                          <a:latin typeface="Noto Sans CJK SC" pitchFamily="34" charset="0"/>
+                          <a:ea typeface="Noto Sans CJK SC" pitchFamily="34" charset="-122"/>
+                          <a:cs typeface="Noto Sans CJK SC" pitchFamily="34" charset="-120"/>
+                        </a:rPr>
+                        <a:t>2024-09-28</a:t>
+                      </a:r>
+                      <a:endParaRPr lang="en-US" sz="1500" dirty="0">
+                        <a:latin typeface="Noto Sans CJK SC" charset="0"/>
+                        <a:ea typeface="Noto Sans CJK SC" charset="0"/>
+                        <a:cs typeface="Noto Sans CJK SC" charset="0"/>
+                      </a:endParaRPr>
+                    </a:p>
+                  </a:txBody>
+                  <a:tcPr marL="36576" marR="36576" marT="36576" marB="36576">
+                    <a:lnL w="12700" cap="flat" cmpd="sng" algn="ctr">
+                      <a:solidFill>
+                        <a:srgbClr val="087D83"/>
+                      </a:solidFill>
+                      <a:prstDash val="solid"/>
+                      <a:round/>
+                      <a:headEnd type="none" w="med" len="med"/>
+                      <a:tailEnd type="none" w="med" len="med"/>
+                    </a:lnL>
+                    <a:lnR w="12700" cap="flat" cmpd="sng" algn="ctr">
+                      <a:solidFill>
+                        <a:srgbClr val="087D83"/>
+                      </a:solidFill>
+                      <a:prstDash val="solid"/>
+                      <a:round/>
+                      <a:headEnd type="none" w="med" len="med"/>
+                      <a:tailEnd type="none" w="med" len="med"/>
+                    </a:lnR>
+                    <a:lnT w="12700" cap="flat" cmpd="sng" algn="ctr">
+                      <a:solidFill>
+                        <a:srgbClr val="087D83"/>
+                      </a:solidFill>
+                      <a:prstDash val="solid"/>
+                      <a:round/>
+                      <a:headEnd type="none" w="med" len="med"/>
+                      <a:tailEnd type="none" w="med" len="med"/>
+                    </a:lnT>
+                    <a:lnB w="12700" cap="flat" cmpd="sng" algn="ctr">
+                      <a:solidFill>
+                        <a:srgbClr val="087D83"/>
+                      </a:solidFill>
+                      <a:prstDash val="solid"/>
+                      <a:round/>
+                      <a:headEnd type="none" w="med" len="med"/>
+                      <a:tailEnd type="none" w="med" len="med"/>
+                    </a:lnB>
+                  </a:tcPr>
+                </a:tc>
+                <a:tc>
+                  <a:txBody>
+                    <a:bodyPr/>
+                    <a:lstStyle/>
+                    <a:p>
+                      <a:pPr indent="0" marL="0">
+                        <a:buNone/>
+                      </a:pPr>
+                      <a:r>
+                        <a:rPr lang="en-US" sz="1500" dirty="0">
+                          <a:solidFill>
+                            <a:srgbClr val="173248"/>
+                          </a:solidFill>
+                          <a:latin typeface="Noto Sans CJK SC" pitchFamily="34" charset="0"/>
+                          <a:ea typeface="Noto Sans CJK SC" pitchFamily="34" charset="-122"/>
+                          <a:cs typeface="Noto Sans CJK SC" pitchFamily="34" charset="-120"/>
+                        </a:rPr>
+                        <a:t>2024-03-31</a:t>
+                      </a:r>
+                      <a:endParaRPr lang="en-US" sz="1500" dirty="0">
+                        <a:latin typeface="Noto Sans CJK SC" charset="0"/>
+                        <a:ea typeface="Noto Sans CJK SC" charset="0"/>
+                        <a:cs typeface="Noto Sans CJK SC" charset="0"/>
+                      </a:endParaRPr>
+                    </a:p>
+                  </a:txBody>
+                  <a:tcPr marL="36576" marR="36576" marT="36576" marB="36576">
+                    <a:lnL w="12700" cap="flat" cmpd="sng" algn="ctr">
+                      <a:solidFill>
+                        <a:srgbClr val="087D83"/>
+                      </a:solidFill>
+                      <a:prstDash val="solid"/>
+                      <a:round/>
+                      <a:headEnd type="none" w="med" len="med"/>
+                      <a:tailEnd type="none" w="med" len="med"/>
+                    </a:lnL>
+                    <a:lnR w="12700" cap="flat" cmpd="sng" algn="ctr">
+                      <a:solidFill>
+                        <a:srgbClr val="087D83"/>
+                      </a:solidFill>
+                      <a:prstDash val="solid"/>
+                      <a:round/>
+                      <a:headEnd type="none" w="med" len="med"/>
+                      <a:tailEnd type="none" w="med" len="med"/>
+                    </a:lnR>
+                    <a:lnT w="12700" cap="flat" cmpd="sng" algn="ctr">
+                      <a:solidFill>
+                        <a:srgbClr val="087D83"/>
+                      </a:solidFill>
+                      <a:prstDash val="solid"/>
+                      <a:round/>
+                      <a:headEnd type="none" w="med" len="med"/>
+                      <a:tailEnd type="none" w="med" len="med"/>
+                    </a:lnT>
+                    <a:lnB w="12700" cap="flat" cmpd="sng" algn="ctr">
+                      <a:solidFill>
+                        <a:srgbClr val="087D83"/>
+                      </a:solidFill>
+                      <a:prstDash val="solid"/>
+                      <a:round/>
+                      <a:headEnd type="none" w="med" len="med"/>
+                      <a:tailEnd type="none" w="med" len="med"/>
+                    </a:lnB>
+                  </a:tcPr>
+                </a:tc>
+              </a:tr>
+              <a:tr h="603504">
+                <a:tc>
+                  <a:txBody>
+                    <a:bodyPr/>
+                    <a:lstStyle/>
+                    <a:p>
+                      <a:pPr indent="0" marL="0">
+                        <a:buNone/>
+                      </a:pPr>
+                      <a:r>
+                        <a:rPr lang="en-US" sz="1500" dirty="0">
+                          <a:solidFill>
+                            <a:srgbClr val="173248"/>
+                          </a:solidFill>
+                          <a:latin typeface="Noto Sans CJK SC" pitchFamily="34" charset="0"/>
+                          <a:ea typeface="Noto Sans CJK SC" pitchFamily="34" charset="-122"/>
+                          <a:cs typeface="Noto Sans CJK SC" pitchFamily="34" charset="-120"/>
+                        </a:rPr>
+                        <a:t>会计准则</a:t>
+                      </a:r>
+                      <a:endParaRPr lang="en-US" sz="1500" dirty="0">
+                        <a:latin typeface="Noto Sans CJK SC" charset="0"/>
+                        <a:ea typeface="Noto Sans CJK SC" charset="0"/>
+                        <a:cs typeface="Noto Sans CJK SC" charset="0"/>
+                      </a:endParaRPr>
+                    </a:p>
+                  </a:txBody>
+                  <a:tcPr marL="36576" marR="36576" marT="36576" marB="36576">
+                    <a:lnL w="12700" cap="flat" cmpd="sng" algn="ctr">
+                      <a:solidFill>
+                        <a:srgbClr val="087D83"/>
+                      </a:solidFill>
+                      <a:prstDash val="solid"/>
+                      <a:round/>
+                      <a:headEnd type="none" w="med" len="med"/>
+                      <a:tailEnd type="none" w="med" len="med"/>
+                    </a:lnL>
+                    <a:lnR w="12700" cap="flat" cmpd="sng" algn="ctr">
+                      <a:solidFill>
+                        <a:srgbClr val="087D83"/>
+                      </a:solidFill>
+                      <a:prstDash val="solid"/>
+                      <a:round/>
+                      <a:headEnd type="none" w="med" len="med"/>
+                      <a:tailEnd type="none" w="med" len="med"/>
+                    </a:lnR>
+                    <a:lnT w="12700" cap="flat" cmpd="sng" algn="ctr">
+                      <a:solidFill>
+                        <a:srgbClr val="087D83"/>
+                      </a:solidFill>
+                      <a:prstDash val="solid"/>
+                      <a:round/>
+                      <a:headEnd type="none" w="med" len="med"/>
+                      <a:tailEnd type="none" w="med" len="med"/>
+                    </a:lnT>
+                    <a:lnB w="12700" cap="flat" cmpd="sng" algn="ctr">
+                      <a:solidFill>
+                        <a:srgbClr val="087D83"/>
+                      </a:solidFill>
+                      <a:prstDash val="solid"/>
+                      <a:round/>
+                      <a:headEnd type="none" w="med" len="med"/>
+                      <a:tailEnd type="none" w="med" len="med"/>
+                    </a:lnB>
+                  </a:tcPr>
+                </a:tc>
+                <a:tc>
+                  <a:txBody>
+                    <a:bodyPr/>
+                    <a:lstStyle/>
+                    <a:p>
+                      <a:pPr indent="0" marL="0">
+                        <a:buNone/>
+                      </a:pPr>
+                      <a:r>
+                        <a:rPr lang="en-US" sz="1500" dirty="0">
+                          <a:solidFill>
+                            <a:srgbClr val="173248"/>
+                          </a:solidFill>
+                          <a:latin typeface="Noto Sans CJK SC" pitchFamily="34" charset="0"/>
+                          <a:ea typeface="Noto Sans CJK SC" pitchFamily="34" charset="-122"/>
+                          <a:cs typeface="Noto Sans CJK SC" pitchFamily="34" charset="-120"/>
+                        </a:rPr>
+                        <a:t>US GAAP</a:t>
+                      </a:r>
+                      <a:endParaRPr lang="en-US" sz="1500" dirty="0">
+                        <a:latin typeface="Noto Sans CJK SC" charset="0"/>
+                        <a:ea typeface="Noto Sans CJK SC" charset="0"/>
+                        <a:cs typeface="Noto Sans CJK SC" charset="0"/>
+                      </a:endParaRPr>
+                    </a:p>
+                  </a:txBody>
+                  <a:tcPr marL="36576" marR="36576" marT="36576" marB="36576">
+                    <a:lnL w="12700" cap="flat" cmpd="sng" algn="ctr">
+                      <a:solidFill>
+                        <a:srgbClr val="087D83"/>
+                      </a:solidFill>
+                      <a:prstDash val="solid"/>
+                      <a:round/>
+                      <a:headEnd type="none" w="med" len="med"/>
+                      <a:tailEnd type="none" w="med" len="med"/>
+                    </a:lnL>
+                    <a:lnR w="12700" cap="flat" cmpd="sng" algn="ctr">
+                      <a:solidFill>
+                        <a:srgbClr val="087D83"/>
+                      </a:solidFill>
+                      <a:prstDash val="solid"/>
+                      <a:round/>
+                      <a:headEnd type="none" w="med" len="med"/>
+                      <a:tailEnd type="none" w="med" len="med"/>
+                    </a:lnR>
+                    <a:lnT w="12700" cap="flat" cmpd="sng" algn="ctr">
+                      <a:solidFill>
+                        <a:srgbClr val="087D83"/>
+                      </a:solidFill>
+                      <a:prstDash val="solid"/>
+                      <a:round/>
+                      <a:headEnd type="none" w="med" len="med"/>
+                      <a:tailEnd type="none" w="med" len="med"/>
+                    </a:lnT>
+                    <a:lnB w="12700" cap="flat" cmpd="sng" algn="ctr">
+                      <a:solidFill>
+                        <a:srgbClr val="087D83"/>
+                      </a:solidFill>
+                      <a:prstDash val="solid"/>
+                      <a:round/>
+                      <a:headEnd type="none" w="med" len="med"/>
+                      <a:tailEnd type="none" w="med" len="med"/>
+                    </a:lnB>
+                  </a:tcPr>
+                </a:tc>
+                <a:tc>
+                  <a:txBody>
+                    <a:bodyPr/>
+                    <a:lstStyle/>
+                    <a:p>
+                      <a:pPr indent="0" marL="0">
+                        <a:buNone/>
+                      </a:pPr>
+                      <a:r>
+                        <a:rPr lang="en-US" sz="1500" dirty="0">
+                          <a:solidFill>
+                            <a:srgbClr val="173248"/>
+                          </a:solidFill>
+                          <a:latin typeface="Noto Sans CJK SC" pitchFamily="34" charset="0"/>
+                          <a:ea typeface="Noto Sans CJK SC" pitchFamily="34" charset="-122"/>
+                          <a:cs typeface="Noto Sans CJK SC" pitchFamily="34" charset="-120"/>
+                        </a:rPr>
+                        <a:t>IFRS</a:t>
+                      </a:r>
+                      <a:endParaRPr lang="en-US" sz="1500" dirty="0">
+                        <a:latin typeface="Noto Sans CJK SC" charset="0"/>
+                        <a:ea typeface="Noto Sans CJK SC" charset="0"/>
+                        <a:cs typeface="Noto Sans CJK SC" charset="0"/>
+                      </a:endParaRPr>
+                    </a:p>
+                  </a:txBody>
+                  <a:tcPr marL="36576" marR="36576" marT="36576" marB="36576">
+                    <a:lnL w="12700" cap="flat" cmpd="sng" algn="ctr">
+                      <a:solidFill>
+                        <a:srgbClr val="087D83"/>
+                      </a:solidFill>
+                      <a:prstDash val="solid"/>
+                      <a:round/>
+                      <a:headEnd type="none" w="med" len="med"/>
+                      <a:tailEnd type="none" w="med" len="med"/>
+                    </a:lnL>
+                    <a:lnR w="12700" cap="flat" cmpd="sng" algn="ctr">
+                      <a:solidFill>
+                        <a:srgbClr val="087D83"/>
+                      </a:solidFill>
+                      <a:prstDash val="solid"/>
+                      <a:round/>
+                      <a:headEnd type="none" w="med" len="med"/>
+                      <a:tailEnd type="none" w="med" len="med"/>
+                    </a:lnR>
+                    <a:lnT w="12700" cap="flat" cmpd="sng" algn="ctr">
+                      <a:solidFill>
+                        <a:srgbClr val="087D83"/>
+                      </a:solidFill>
+                      <a:prstDash val="solid"/>
+                      <a:round/>
+                      <a:headEnd type="none" w="med" len="med"/>
+                      <a:tailEnd type="none" w="med" len="med"/>
+                    </a:lnT>
+                    <a:lnB w="12700" cap="flat" cmpd="sng" algn="ctr">
+                      <a:solidFill>
+                        <a:srgbClr val="087D83"/>
+                      </a:solidFill>
+                      <a:prstDash val="solid"/>
+                      <a:round/>
+                      <a:headEnd type="none" w="med" len="med"/>
+                      <a:tailEnd type="none" w="med" len="med"/>
+                    </a:lnB>
+                  </a:tcPr>
+                </a:tc>
+              </a:tr>
+              <a:tr h="603504">
+                <a:tc>
+                  <a:txBody>
+                    <a:bodyPr/>
+                    <a:lstStyle/>
+                    <a:p>
+                      <a:pPr indent="0" marL="0">
+                        <a:buNone/>
+                      </a:pPr>
+                      <a:r>
+                        <a:rPr lang="en-US" sz="1500" dirty="0">
+                          <a:solidFill>
+                            <a:srgbClr val="173248"/>
+                          </a:solidFill>
+                          <a:latin typeface="Noto Sans CJK SC" pitchFamily="34" charset="0"/>
+                          <a:ea typeface="Noto Sans CJK SC" pitchFamily="34" charset="-122"/>
+                          <a:cs typeface="Noto Sans CJK SC" pitchFamily="34" charset="-120"/>
+                        </a:rPr>
+                        <a:t>币种与单位</a:t>
+                      </a:r>
+                      <a:endParaRPr lang="en-US" sz="1500" dirty="0">
+                        <a:latin typeface="Noto Sans CJK SC" charset="0"/>
+                        <a:ea typeface="Noto Sans CJK SC" charset="0"/>
+                        <a:cs typeface="Noto Sans CJK SC" charset="0"/>
+                      </a:endParaRPr>
+                    </a:p>
+                  </a:txBody>
+                  <a:tcPr marL="36576" marR="36576" marT="36576" marB="36576">
+                    <a:lnL w="12700" cap="flat" cmpd="sng" algn="ctr">
+                      <a:solidFill>
+                        <a:srgbClr val="087D83"/>
+                      </a:solidFill>
+                      <a:prstDash val="solid"/>
+                      <a:round/>
+                      <a:headEnd type="none" w="med" len="med"/>
+                      <a:tailEnd type="none" w="med" len="med"/>
+                    </a:lnL>
+                    <a:lnR w="12700" cap="flat" cmpd="sng" algn="ctr">
+                      <a:solidFill>
+                        <a:srgbClr val="087D83"/>
+                      </a:solidFill>
+                      <a:prstDash val="solid"/>
+                      <a:round/>
+                      <a:headEnd type="none" w="med" len="med"/>
+                      <a:tailEnd type="none" w="med" len="med"/>
+                    </a:lnR>
+                    <a:lnT w="12700" cap="flat" cmpd="sng" algn="ctr">
+                      <a:solidFill>
+                        <a:srgbClr val="087D83"/>
+                      </a:solidFill>
+                      <a:prstDash val="solid"/>
+                      <a:round/>
+                      <a:headEnd type="none" w="med" len="med"/>
+                      <a:tailEnd type="none" w="med" len="med"/>
+                    </a:lnT>
+                    <a:lnB w="12700" cap="flat" cmpd="sng" algn="ctr">
+                      <a:solidFill>
+                        <a:srgbClr val="087D83"/>
+                      </a:solidFill>
+                      <a:prstDash val="solid"/>
+                      <a:round/>
+                      <a:headEnd type="none" w="med" len="med"/>
+                      <a:tailEnd type="none" w="med" len="med"/>
+                    </a:lnB>
+                  </a:tcPr>
+                </a:tc>
+                <a:tc>
+                  <a:txBody>
+                    <a:bodyPr/>
+                    <a:lstStyle/>
+                    <a:p>
+                      <a:pPr indent="0" marL="0">
+                        <a:buNone/>
+                      </a:pPr>
+                      <a:r>
+                        <a:rPr lang="en-US" sz="1500" dirty="0">
+                          <a:solidFill>
+                            <a:srgbClr val="173248"/>
+                          </a:solidFill>
+                          <a:latin typeface="Noto Sans CJK SC" pitchFamily="34" charset="0"/>
+                          <a:ea typeface="Noto Sans CJK SC" pitchFamily="34" charset="-122"/>
+                          <a:cs typeface="Noto Sans CJK SC" pitchFamily="34" charset="-120"/>
+                        </a:rPr>
+                        <a:t>USD millions</a:t>
+                      </a:r>
+                      <a:endParaRPr lang="en-US" sz="1500" dirty="0">
+                        <a:latin typeface="Noto Sans CJK SC" charset="0"/>
+                        <a:ea typeface="Noto Sans CJK SC" charset="0"/>
+                        <a:cs typeface="Noto Sans CJK SC" charset="0"/>
+                      </a:endParaRPr>
+                    </a:p>
+                  </a:txBody>
+                  <a:tcPr marL="36576" marR="36576" marT="36576" marB="36576">
+                    <a:lnL w="12700" cap="flat" cmpd="sng" algn="ctr">
+                      <a:solidFill>
+                        <a:srgbClr val="087D83"/>
+                      </a:solidFill>
+                      <a:prstDash val="solid"/>
+                      <a:round/>
+                      <a:headEnd type="none" w="med" len="med"/>
+                      <a:tailEnd type="none" w="med" len="med"/>
+                    </a:lnL>
+                    <a:lnR w="12700" cap="flat" cmpd="sng" algn="ctr">
+                      <a:solidFill>
+                        <a:srgbClr val="087D83"/>
+                      </a:solidFill>
+                      <a:prstDash val="solid"/>
+                      <a:round/>
+                      <a:headEnd type="none" w="med" len="med"/>
+                      <a:tailEnd type="none" w="med" len="med"/>
+                    </a:lnR>
+                    <a:lnT w="12700" cap="flat" cmpd="sng" algn="ctr">
+                      <a:solidFill>
+                        <a:srgbClr val="087D83"/>
+                      </a:solidFill>
+                      <a:prstDash val="solid"/>
+                      <a:round/>
+                      <a:headEnd type="none" w="med" len="med"/>
+                      <a:tailEnd type="none" w="med" len="med"/>
+                    </a:lnT>
+                    <a:lnB w="12700" cap="flat" cmpd="sng" algn="ctr">
+                      <a:solidFill>
+                        <a:srgbClr val="087D83"/>
+                      </a:solidFill>
+                      <a:prstDash val="solid"/>
+                      <a:round/>
+                      <a:headEnd type="none" w="med" len="med"/>
+                      <a:tailEnd type="none" w="med" len="med"/>
+                    </a:lnB>
+                  </a:tcPr>
+                </a:tc>
+                <a:tc>
+                  <a:txBody>
+                    <a:bodyPr/>
+                    <a:lstStyle/>
+                    <a:p>
+                      <a:pPr indent="0" marL="0">
+                        <a:buNone/>
+                      </a:pPr>
+                      <a:r>
+                        <a:rPr lang="en-US" sz="1500" dirty="0">
+                          <a:solidFill>
+                            <a:srgbClr val="173248"/>
+                          </a:solidFill>
+                          <a:latin typeface="Noto Sans CJK SC" pitchFamily="34" charset="0"/>
+                          <a:ea typeface="Noto Sans CJK SC" pitchFamily="34" charset="-122"/>
+                          <a:cs typeface="Noto Sans CJK SC" pitchFamily="34" charset="-120"/>
+                        </a:rPr>
+                        <a:t>JPY millions</a:t>
+                      </a:r>
+                      <a:endParaRPr lang="en-US" sz="1500" dirty="0">
+                        <a:latin typeface="Noto Sans CJK SC" charset="0"/>
+                        <a:ea typeface="Noto Sans CJK SC" charset="0"/>
+                        <a:cs typeface="Noto Sans CJK SC" charset="0"/>
+                      </a:endParaRPr>
+                    </a:p>
+                  </a:txBody>
+                  <a:tcPr marL="36576" marR="36576" marT="36576" marB="36576">
+                    <a:lnL w="12700" cap="flat" cmpd="sng" algn="ctr">
+                      <a:solidFill>
+                        <a:srgbClr val="087D83"/>
+                      </a:solidFill>
+                      <a:prstDash val="solid"/>
+                      <a:round/>
+                      <a:headEnd type="none" w="med" len="med"/>
+                      <a:tailEnd type="none" w="med" len="med"/>
+                    </a:lnL>
+                    <a:lnR w="12700" cap="flat" cmpd="sng" algn="ctr">
+                      <a:solidFill>
+                        <a:srgbClr val="087D83"/>
+                      </a:solidFill>
+                      <a:prstDash val="solid"/>
+                      <a:round/>
+                      <a:headEnd type="none" w="med" len="med"/>
+                      <a:tailEnd type="none" w="med" len="med"/>
+                    </a:lnR>
+                    <a:lnT w="12700" cap="flat" cmpd="sng" algn="ctr">
+                      <a:solidFill>
+                        <a:srgbClr val="087D83"/>
+                      </a:solidFill>
+                      <a:prstDash val="solid"/>
+                      <a:round/>
+                      <a:headEnd type="none" w="med" len="med"/>
+                      <a:tailEnd type="none" w="med" len="med"/>
+                    </a:lnT>
+                    <a:lnB w="12700" cap="flat" cmpd="sng" algn="ctr">
+                      <a:solidFill>
+                        <a:srgbClr val="087D83"/>
+                      </a:solidFill>
+                      <a:prstDash val="solid"/>
+                      <a:round/>
+                      <a:headEnd type="none" w="med" len="med"/>
+                      <a:tailEnd type="none" w="med" len="med"/>
+                    </a:lnB>
+                  </a:tcPr>
+                </a:tc>
+              </a:tr>
+              <a:tr h="603504">
+                <a:tc>
+                  <a:txBody>
+                    <a:bodyPr/>
+                    <a:lstStyle/>
+                    <a:p>
+                      <a:pPr indent="0" marL="0">
+                        <a:buNone/>
+                      </a:pPr>
+                      <a:r>
+                        <a:rPr lang="en-US" sz="1500" dirty="0">
+                          <a:solidFill>
+                            <a:srgbClr val="173248"/>
+                          </a:solidFill>
+                          <a:latin typeface="Noto Sans CJK SC" pitchFamily="34" charset="0"/>
+                          <a:ea typeface="Noto Sans CJK SC" pitchFamily="34" charset="-122"/>
+                          <a:cs typeface="Noto Sans CJK SC" pitchFamily="34" charset="-120"/>
+                        </a:rPr>
+                        <a:t>收入范围</a:t>
+                      </a:r>
+                      <a:endParaRPr lang="en-US" sz="1500" dirty="0">
+                        <a:latin typeface="Noto Sans CJK SC" charset="0"/>
+                        <a:ea typeface="Noto Sans CJK SC" charset="0"/>
+                        <a:cs typeface="Noto Sans CJK SC" charset="0"/>
+                      </a:endParaRPr>
+                    </a:p>
+                  </a:txBody>
+                  <a:tcPr marL="36576" marR="36576" marT="36576" marB="36576">
+                    <a:lnL w="12700" cap="flat" cmpd="sng" algn="ctr">
+                      <a:solidFill>
+                        <a:srgbClr val="087D83"/>
+                      </a:solidFill>
+                      <a:prstDash val="solid"/>
+                      <a:round/>
+                      <a:headEnd type="none" w="med" len="med"/>
+                      <a:tailEnd type="none" w="med" len="med"/>
+                    </a:lnL>
+                    <a:lnR w="12700" cap="flat" cmpd="sng" algn="ctr">
+                      <a:solidFill>
+                        <a:srgbClr val="087D83"/>
+                      </a:solidFill>
+                      <a:prstDash val="solid"/>
+                      <a:round/>
+                      <a:headEnd type="none" w="med" len="med"/>
+                      <a:tailEnd type="none" w="med" len="med"/>
+                    </a:lnR>
+                    <a:lnT w="12700" cap="flat" cmpd="sng" algn="ctr">
+                      <a:solidFill>
+                        <a:srgbClr val="087D83"/>
+                      </a:solidFill>
+                      <a:prstDash val="solid"/>
+                      <a:round/>
+                      <a:headEnd type="none" w="med" len="med"/>
+                      <a:tailEnd type="none" w="med" len="med"/>
+                    </a:lnT>
+                    <a:lnB w="12700" cap="flat" cmpd="sng" algn="ctr">
+                      <a:solidFill>
+                        <a:srgbClr val="087D83"/>
+                      </a:solidFill>
+                      <a:prstDash val="solid"/>
+                      <a:round/>
+                      <a:headEnd type="none" w="med" len="med"/>
+                      <a:tailEnd type="none" w="med" len="med"/>
+                    </a:lnB>
+                  </a:tcPr>
+                </a:tc>
+                <a:tc>
+                  <a:txBody>
+                    <a:bodyPr/>
+                    <a:lstStyle/>
+                    <a:p>
+                      <a:pPr indent="0" marL="0">
+                        <a:buNone/>
+                      </a:pPr>
+                      <a:r>
+                        <a:rPr lang="en-US" sz="1500" dirty="0">
+                          <a:solidFill>
+                            <a:srgbClr val="173248"/>
+                          </a:solidFill>
+                          <a:latin typeface="Noto Sans CJK SC" pitchFamily="34" charset="0"/>
+                          <a:ea typeface="Noto Sans CJK SC" pitchFamily="34" charset="-122"/>
+                          <a:cs typeface="Noto Sans CJK SC" pitchFamily="34" charset="-120"/>
+                        </a:rPr>
+                        <a:t>Net sales</a:t>
+                      </a:r>
+                      <a:endParaRPr lang="en-US" sz="1500" dirty="0">
+                        <a:latin typeface="Noto Sans CJK SC" charset="0"/>
+                        <a:ea typeface="Noto Sans CJK SC" charset="0"/>
+                        <a:cs typeface="Noto Sans CJK SC" charset="0"/>
+                      </a:endParaRPr>
+                    </a:p>
+                  </a:txBody>
+                  <a:tcPr marL="36576" marR="36576" marT="36576" marB="36576">
+                    <a:lnL w="12700" cap="flat" cmpd="sng" algn="ctr">
+                      <a:solidFill>
+                        <a:srgbClr val="087D83"/>
+                      </a:solidFill>
+                      <a:prstDash val="solid"/>
+                      <a:round/>
+                      <a:headEnd type="none" w="med" len="med"/>
+                      <a:tailEnd type="none" w="med" len="med"/>
+                    </a:lnL>
+                    <a:lnR w="12700" cap="flat" cmpd="sng" algn="ctr">
+                      <a:solidFill>
+                        <a:srgbClr val="087D83"/>
+                      </a:solidFill>
+                      <a:prstDash val="solid"/>
+                      <a:round/>
+                      <a:headEnd type="none" w="med" len="med"/>
+                      <a:tailEnd type="none" w="med" len="med"/>
+                    </a:lnR>
+                    <a:lnT w="12700" cap="flat" cmpd="sng" algn="ctr">
+                      <a:solidFill>
+                        <a:srgbClr val="087D83"/>
+                      </a:solidFill>
+                      <a:prstDash val="solid"/>
+                      <a:round/>
+                      <a:headEnd type="none" w="med" len="med"/>
+                      <a:tailEnd type="none" w="med" len="med"/>
+                    </a:lnT>
+                    <a:lnB w="12700" cap="flat" cmpd="sng" algn="ctr">
+                      <a:solidFill>
+                        <a:srgbClr val="087D83"/>
+                      </a:solidFill>
+                      <a:prstDash val="solid"/>
+                      <a:round/>
+                      <a:headEnd type="none" w="med" len="med"/>
+                      <a:tailEnd type="none" w="med" len="med"/>
+                    </a:lnB>
+                  </a:tcPr>
+                </a:tc>
+                <a:tc>
+                  <a:txBody>
+                    <a:bodyPr/>
+                    <a:lstStyle/>
+                    <a:p>
+                      <a:pPr indent="0" marL="0">
+                        <a:buNone/>
+                      </a:pPr>
+                      <a:r>
+                        <a:rPr lang="en-US" sz="1500" dirty="0">
+                          <a:solidFill>
+                            <a:srgbClr val="173248"/>
+                          </a:solidFill>
+                          <a:latin typeface="Noto Sans CJK SC" pitchFamily="34" charset="0"/>
+                          <a:ea typeface="Noto Sans CJK SC" pitchFamily="34" charset="-122"/>
+                          <a:cs typeface="Noto Sans CJK SC" pitchFamily="34" charset="-120"/>
+                        </a:rPr>
+                        <a:t>Total sales and financial services revenue</a:t>
+                      </a:r>
+                      <a:endParaRPr lang="en-US" sz="1500" dirty="0">
+                        <a:latin typeface="Noto Sans CJK SC" charset="0"/>
+                        <a:ea typeface="Noto Sans CJK SC" charset="0"/>
+                        <a:cs typeface="Noto Sans CJK SC" charset="0"/>
+                      </a:endParaRPr>
+                    </a:p>
+                  </a:txBody>
+                  <a:tcPr marL="36576" marR="36576" marT="36576" marB="36576">
+                    <a:lnL w="12700" cap="flat" cmpd="sng" algn="ctr">
+                      <a:solidFill>
+                        <a:srgbClr val="087D83"/>
+                      </a:solidFill>
+                      <a:prstDash val="solid"/>
+                      <a:round/>
+                      <a:headEnd type="none" w="med" len="med"/>
+                      <a:tailEnd type="none" w="med" len="med"/>
+                    </a:lnL>
+                    <a:lnR w="12700" cap="flat" cmpd="sng" algn="ctr">
+                      <a:solidFill>
+                        <a:srgbClr val="087D83"/>
+                      </a:solidFill>
+                      <a:prstDash val="solid"/>
+                      <a:round/>
+                      <a:headEnd type="none" w="med" len="med"/>
+                      <a:tailEnd type="none" w="med" len="med"/>
+                    </a:lnR>
+                    <a:lnT w="12700" cap="flat" cmpd="sng" algn="ctr">
+                      <a:solidFill>
+                        <a:srgbClr val="087D83"/>
+                      </a:solidFill>
+                      <a:prstDash val="solid"/>
+                      <a:round/>
+                      <a:headEnd type="none" w="med" len="med"/>
+                      <a:tailEnd type="none" w="med" len="med"/>
+                    </a:lnT>
+                    <a:lnB w="12700" cap="flat" cmpd="sng" algn="ctr">
+                      <a:solidFill>
+                        <a:srgbClr val="087D83"/>
+                      </a:solidFill>
+                      <a:prstDash val="solid"/>
+                      <a:round/>
+                      <a:headEnd type="none" w="med" len="med"/>
+                      <a:tailEnd type="none" w="med" len="med"/>
+                    </a:lnB>
+                  </a:tcPr>
+                </a:tc>
+              </a:tr>
+            </a:tbl>
+          </a:graphicData>
+        </a:graphic>
+      </p:graphicFrame>
+      <p:sp>
+        <p:nvSpPr>
+          <p:cNvPr id="5" name="footer"/>
           <p:cNvSpPr/>
           <p:nvPr/>
         </p:nvSpPr>
@@ -3028,7 +4044,7 @@
         <p:spPr>
           <a:xfrm>
             <a:off x="822960" y="1463040"/>
-            <a:ext cx="10424160" cy="3200400"/>
+            <a:ext cx="10424160" cy="731520"/>
           </a:xfrm>
           <a:prstGeom prst="rect">
             <a:avLst/>
@@ -3058,9 +4074,609 @@
           </a:p>
         </p:txBody>
       </p:sp>
-      <p:sp>
-        <p:nvSpPr>
-          <p:cNvPr id="4" name="footer"/>
+      <p:graphicFrame>
+        <p:nvGraphicFramePr>
+          <p:cNvPr id="8" name="comparison-gaps"/>
+          <p:cNvGraphicFramePr>
+            <a:graphicFrameLocks noGrp="1"/>
+          </p:cNvGraphicFramePr>
+          <p:nvPr>
+            <p:extLst>
+              <p:ext uri="{D42A27DB-BD31-4B8C-83A1-F6EECF244321}">
+                <p14:modId xmlns:p14="http://schemas.microsoft.com/office/powerpoint/2010/main" val="1579011935"/>
+              </p:ext>
+            </p:extLst>
+          </p:nvPr>
+        </p:nvGraphicFramePr>
+        <p:xfrm>
+          <a:off x="822960" y="2423160"/>
+          <a:ext cx="10424160" cy="2468880"/>
+        </p:xfrm>
+        <a:graphic>
+          <a:graphicData uri="http://schemas.openxmlformats.org/drawingml/2006/table">
+            <a:tbl>
+              <a:tblPr/>
+              <a:tblGrid>
+                <a:gridCol w="3474720"/>
+                <a:gridCol w="3474720"/>
+                <a:gridCol w="3474720"/>
+              </a:tblGrid>
+              <a:tr h="822960">
+                <a:tc>
+                  <a:txBody>
+                    <a:bodyPr/>
+                    <a:lstStyle/>
+                    <a:p>
+                      <a:pPr indent="0" marL="0">
+                        <a:buNone/>
+                      </a:pPr>
+                      <a:r>
+                        <a:rPr lang="en-US" sz="1600" dirty="0">
+                          <a:solidFill>
+                            <a:srgbClr val="173248"/>
+                          </a:solidFill>
+                          <a:latin typeface="Noto Sans CJK SC" pitchFamily="34" charset="0"/>
+                          <a:ea typeface="Noto Sans CJK SC" pitchFamily="34" charset="-122"/>
+                          <a:cs typeface="Noto Sans CJK SC" pitchFamily="34" charset="-120"/>
+                        </a:rPr>
+                        <a:t>比较项</a:t>
+                      </a:r>
+                      <a:endParaRPr lang="en-US" sz="1600" dirty="0">
+                        <a:latin typeface="Noto Sans CJK SC" charset="0"/>
+                        <a:ea typeface="Noto Sans CJK SC" charset="0"/>
+                        <a:cs typeface="Noto Sans CJK SC" charset="0"/>
+                      </a:endParaRPr>
+                    </a:p>
+                  </a:txBody>
+                  <a:tcPr marL="36576" marR="36576" marT="36576" marB="36576">
+                    <a:lnL w="12700" cap="flat" cmpd="sng" algn="ctr">
+                      <a:solidFill>
+                        <a:srgbClr val="087D83"/>
+                      </a:solidFill>
+                      <a:prstDash val="solid"/>
+                      <a:round/>
+                      <a:headEnd type="none" w="med" len="med"/>
+                      <a:tailEnd type="none" w="med" len="med"/>
+                    </a:lnL>
+                    <a:lnR w="12700" cap="flat" cmpd="sng" algn="ctr">
+                      <a:solidFill>
+                        <a:srgbClr val="087D83"/>
+                      </a:solidFill>
+                      <a:prstDash val="solid"/>
+                      <a:round/>
+                      <a:headEnd type="none" w="med" len="med"/>
+                      <a:tailEnd type="none" w="med" len="med"/>
+                    </a:lnR>
+                    <a:lnT w="12700" cap="flat" cmpd="sng" algn="ctr">
+                      <a:solidFill>
+                        <a:srgbClr val="087D83"/>
+                      </a:solidFill>
+                      <a:prstDash val="solid"/>
+                      <a:round/>
+                      <a:headEnd type="none" w="med" len="med"/>
+                      <a:tailEnd type="none" w="med" len="med"/>
+                    </a:lnT>
+                    <a:lnB w="12700" cap="flat" cmpd="sng" algn="ctr">
+                      <a:solidFill>
+                        <a:srgbClr val="087D83"/>
+                      </a:solidFill>
+                      <a:prstDash val="solid"/>
+                      <a:round/>
+                      <a:headEnd type="none" w="med" len="med"/>
+                      <a:tailEnd type="none" w="med" len="med"/>
+                    </a:lnB>
+                  </a:tcPr>
+                </a:tc>
+                <a:tc>
+                  <a:txBody>
+                    <a:bodyPr/>
+                    <a:lstStyle/>
+                    <a:p>
+                      <a:pPr indent="0" marL="0">
+                        <a:buNone/>
+                      </a:pPr>
+                      <a:r>
+                        <a:rPr lang="en-US" sz="1600" dirty="0">
+                          <a:solidFill>
+                            <a:srgbClr val="173248"/>
+                          </a:solidFill>
+                          <a:latin typeface="Noto Sans CJK SC" pitchFamily="34" charset="0"/>
+                          <a:ea typeface="Noto Sans CJK SC" pitchFamily="34" charset="-122"/>
+                          <a:cs typeface="Noto Sans CJK SC" pitchFamily="34" charset="-120"/>
+                        </a:rPr>
+                        <a:t>结果</a:t>
+                      </a:r>
+                      <a:endParaRPr lang="en-US" sz="1600" dirty="0">
+                        <a:latin typeface="Noto Sans CJK SC" charset="0"/>
+                        <a:ea typeface="Noto Sans CJK SC" charset="0"/>
+                        <a:cs typeface="Noto Sans CJK SC" charset="0"/>
+                      </a:endParaRPr>
+                    </a:p>
+                  </a:txBody>
+                  <a:tcPr marL="36576" marR="36576" marT="36576" marB="36576">
+                    <a:lnL w="12700" cap="flat" cmpd="sng" algn="ctr">
+                      <a:solidFill>
+                        <a:srgbClr val="087D83"/>
+                      </a:solidFill>
+                      <a:prstDash val="solid"/>
+                      <a:round/>
+                      <a:headEnd type="none" w="med" len="med"/>
+                      <a:tailEnd type="none" w="med" len="med"/>
+                    </a:lnL>
+                    <a:lnR w="12700" cap="flat" cmpd="sng" algn="ctr">
+                      <a:solidFill>
+                        <a:srgbClr val="087D83"/>
+                      </a:solidFill>
+                      <a:prstDash val="solid"/>
+                      <a:round/>
+                      <a:headEnd type="none" w="med" len="med"/>
+                      <a:tailEnd type="none" w="med" len="med"/>
+                    </a:lnR>
+                    <a:lnT w="12700" cap="flat" cmpd="sng" algn="ctr">
+                      <a:solidFill>
+                        <a:srgbClr val="087D83"/>
+                      </a:solidFill>
+                      <a:prstDash val="solid"/>
+                      <a:round/>
+                      <a:headEnd type="none" w="med" len="med"/>
+                      <a:tailEnd type="none" w="med" len="med"/>
+                    </a:lnT>
+                    <a:lnB w="12700" cap="flat" cmpd="sng" algn="ctr">
+                      <a:solidFill>
+                        <a:srgbClr val="087D83"/>
+                      </a:solidFill>
+                      <a:prstDash val="solid"/>
+                      <a:round/>
+                      <a:headEnd type="none" w="med" len="med"/>
+                      <a:tailEnd type="none" w="med" len="med"/>
+                    </a:lnB>
+                  </a:tcPr>
+                </a:tc>
+                <a:tc>
+                  <a:txBody>
+                    <a:bodyPr/>
+                    <a:lstStyle/>
+                    <a:p>
+                      <a:pPr indent="0" marL="0">
+                        <a:buNone/>
+                      </a:pPr>
+                      <a:r>
+                        <a:rPr lang="en-US" sz="1600" dirty="0">
+                          <a:solidFill>
+                            <a:srgbClr val="173248"/>
+                          </a:solidFill>
+                          <a:latin typeface="Noto Sans CJK SC" pitchFamily="34" charset="0"/>
+                          <a:ea typeface="Noto Sans CJK SC" pitchFamily="34" charset="-122"/>
+                          <a:cs typeface="Noto Sans CJK SC" pitchFamily="34" charset="-120"/>
+                        </a:rPr>
+                        <a:t>理由</a:t>
+                      </a:r>
+                      <a:endParaRPr lang="en-US" sz="1600" dirty="0">
+                        <a:latin typeface="Noto Sans CJK SC" charset="0"/>
+                        <a:ea typeface="Noto Sans CJK SC" charset="0"/>
+                        <a:cs typeface="Noto Sans CJK SC" charset="0"/>
+                      </a:endParaRPr>
+                    </a:p>
+                  </a:txBody>
+                  <a:tcPr marL="36576" marR="36576" marT="36576" marB="36576">
+                    <a:lnL w="12700" cap="flat" cmpd="sng" algn="ctr">
+                      <a:solidFill>
+                        <a:srgbClr val="087D83"/>
+                      </a:solidFill>
+                      <a:prstDash val="solid"/>
+                      <a:round/>
+                      <a:headEnd type="none" w="med" len="med"/>
+                      <a:tailEnd type="none" w="med" len="med"/>
+                    </a:lnL>
+                    <a:lnR w="12700" cap="flat" cmpd="sng" algn="ctr">
+                      <a:solidFill>
+                        <a:srgbClr val="087D83"/>
+                      </a:solidFill>
+                      <a:prstDash val="solid"/>
+                      <a:round/>
+                      <a:headEnd type="none" w="med" len="med"/>
+                      <a:tailEnd type="none" w="med" len="med"/>
+                    </a:lnR>
+                    <a:lnT w="12700" cap="flat" cmpd="sng" algn="ctr">
+                      <a:solidFill>
+                        <a:srgbClr val="087D83"/>
+                      </a:solidFill>
+                      <a:prstDash val="solid"/>
+                      <a:round/>
+                      <a:headEnd type="none" w="med" len="med"/>
+                      <a:tailEnd type="none" w="med" len="med"/>
+                    </a:lnT>
+                    <a:lnB w="12700" cap="flat" cmpd="sng" algn="ctr">
+                      <a:solidFill>
+                        <a:srgbClr val="087D83"/>
+                      </a:solidFill>
+                      <a:prstDash val="solid"/>
+                      <a:round/>
+                      <a:headEnd type="none" w="med" len="med"/>
+                      <a:tailEnd type="none" w="med" len="med"/>
+                    </a:lnB>
+                  </a:tcPr>
+                </a:tc>
+              </a:tr>
+              <a:tr h="822960">
+                <a:tc>
+                  <a:txBody>
+                    <a:bodyPr/>
+                    <a:lstStyle/>
+                    <a:p>
+                      <a:pPr indent="0" marL="0">
+                        <a:buNone/>
+                      </a:pPr>
+                      <a:r>
+                        <a:rPr lang="en-US" sz="1600" dirty="0">
+                          <a:solidFill>
+                            <a:srgbClr val="173248"/>
+                          </a:solidFill>
+                          <a:latin typeface="Noto Sans CJK SC" pitchFamily="34" charset="0"/>
+                          <a:ea typeface="Noto Sans CJK SC" pitchFamily="34" charset="-122"/>
+                          <a:cs typeface="Noto Sans CJK SC" pitchFamily="34" charset="-120"/>
+                        </a:rPr>
+                        <a:t>同口径美元收入差额</a:t>
+                      </a:r>
+                      <a:endParaRPr lang="en-US" sz="1600" dirty="0">
+                        <a:latin typeface="Noto Sans CJK SC" charset="0"/>
+                        <a:ea typeface="Noto Sans CJK SC" charset="0"/>
+                        <a:cs typeface="Noto Sans CJK SC" charset="0"/>
+                      </a:endParaRPr>
+                    </a:p>
+                  </a:txBody>
+                  <a:tcPr marL="36576" marR="36576" marT="36576" marB="36576">
+                    <a:lnL w="12700" cap="flat" cmpd="sng" algn="ctr">
+                      <a:solidFill>
+                        <a:srgbClr val="087D83"/>
+                      </a:solidFill>
+                      <a:prstDash val="solid"/>
+                      <a:round/>
+                      <a:headEnd type="none" w="med" len="med"/>
+                      <a:tailEnd type="none" w="med" len="med"/>
+                    </a:lnL>
+                    <a:lnR w="12700" cap="flat" cmpd="sng" algn="ctr">
+                      <a:solidFill>
+                        <a:srgbClr val="087D83"/>
+                      </a:solidFill>
+                      <a:prstDash val="solid"/>
+                      <a:round/>
+                      <a:headEnd type="none" w="med" len="med"/>
+                      <a:tailEnd type="none" w="med" len="med"/>
+                    </a:lnR>
+                    <a:lnT w="12700" cap="flat" cmpd="sng" algn="ctr">
+                      <a:solidFill>
+                        <a:srgbClr val="087D83"/>
+                      </a:solidFill>
+                      <a:prstDash val="solid"/>
+                      <a:round/>
+                      <a:headEnd type="none" w="med" len="med"/>
+                      <a:tailEnd type="none" w="med" len="med"/>
+                    </a:lnT>
+                    <a:lnB w="12700" cap="flat" cmpd="sng" algn="ctr">
+                      <a:solidFill>
+                        <a:srgbClr val="087D83"/>
+                      </a:solidFill>
+                      <a:prstDash val="solid"/>
+                      <a:round/>
+                      <a:headEnd type="none" w="med" len="med"/>
+                      <a:tailEnd type="none" w="med" len="med"/>
+                    </a:lnB>
+                  </a:tcPr>
+                </a:tc>
+                <a:tc>
+                  <a:txBody>
+                    <a:bodyPr/>
+                    <a:lstStyle/>
+                    <a:p>
+                      <a:pPr indent="0" marL="0">
+                        <a:buNone/>
+                      </a:pPr>
+                      <a:endParaRPr lang="en-US" sz="1600" dirty="0">
+                        <a:latin typeface="Noto Sans CJK SC" charset="0"/>
+                        <a:ea typeface="Noto Sans CJK SC" charset="0"/>
+                        <a:cs typeface="Noto Sans CJK SC" charset="0"/>
+                      </a:endParaRPr>
+                    </a:p>
+                  </a:txBody>
+                  <a:tcPr marL="36576" marR="36576" marT="36576" marB="36576">
+                    <a:lnL w="12700" cap="flat" cmpd="sng" algn="ctr">
+                      <a:solidFill>
+                        <a:srgbClr val="087D83"/>
+                      </a:solidFill>
+                      <a:prstDash val="solid"/>
+                      <a:round/>
+                      <a:headEnd type="none" w="med" len="med"/>
+                      <a:tailEnd type="none" w="med" len="med"/>
+                    </a:lnL>
+                    <a:lnR w="12700" cap="flat" cmpd="sng" algn="ctr">
+                      <a:solidFill>
+                        <a:srgbClr val="087D83"/>
+                      </a:solidFill>
+                      <a:prstDash val="solid"/>
+                      <a:round/>
+                      <a:headEnd type="none" w="med" len="med"/>
+                      <a:tailEnd type="none" w="med" len="med"/>
+                    </a:lnR>
+                    <a:lnT w="12700" cap="flat" cmpd="sng" algn="ctr">
+                      <a:solidFill>
+                        <a:srgbClr val="087D83"/>
+                      </a:solidFill>
+                      <a:prstDash val="solid"/>
+                      <a:round/>
+                      <a:headEnd type="none" w="med" len="med"/>
+                      <a:tailEnd type="none" w="med" len="med"/>
+                    </a:lnT>
+                    <a:lnB w="12700" cap="flat" cmpd="sng" algn="ctr">
+                      <a:solidFill>
+                        <a:srgbClr val="087D83"/>
+                      </a:solidFill>
+                      <a:prstDash val="solid"/>
+                      <a:round/>
+                      <a:headEnd type="none" w="med" len="med"/>
+                      <a:tailEnd type="none" w="med" len="med"/>
+                    </a:lnB>
+                  </a:tcPr>
+                </a:tc>
+                <a:tc>
+                  <a:txBody>
+                    <a:bodyPr/>
+                    <a:lstStyle/>
+                    <a:p>
+                      <a:pPr indent="0" marL="0">
+                        <a:buNone/>
+                      </a:pPr>
+                      <a:r>
+                        <a:rPr lang="en-US" sz="1600" dirty="0">
+                          <a:solidFill>
+                            <a:srgbClr val="173248"/>
+                          </a:solidFill>
+                          <a:latin typeface="Noto Sans CJK SC" pitchFamily="34" charset="0"/>
+                          <a:ea typeface="Noto Sans CJK SC" pitchFamily="34" charset="-122"/>
+                          <a:cs typeface="Noto Sans CJK SC" pitchFamily="34" charset="-120"/>
+                        </a:rPr>
+                        <a:t>财年、准则和范围不同</a:t>
+                      </a:r>
+                      <a:endParaRPr lang="en-US" sz="1600" dirty="0">
+                        <a:latin typeface="Noto Sans CJK SC" charset="0"/>
+                        <a:ea typeface="Noto Sans CJK SC" charset="0"/>
+                        <a:cs typeface="Noto Sans CJK SC" charset="0"/>
+                      </a:endParaRPr>
+                    </a:p>
+                  </a:txBody>
+                  <a:tcPr marL="36576" marR="36576" marT="36576" marB="36576">
+                    <a:lnL w="12700" cap="flat" cmpd="sng" algn="ctr">
+                      <a:solidFill>
+                        <a:srgbClr val="087D83"/>
+                      </a:solidFill>
+                      <a:prstDash val="solid"/>
+                      <a:round/>
+                      <a:headEnd type="none" w="med" len="med"/>
+                      <a:tailEnd type="none" w="med" len="med"/>
+                    </a:lnL>
+                    <a:lnR w="12700" cap="flat" cmpd="sng" algn="ctr">
+                      <a:solidFill>
+                        <a:srgbClr val="087D83"/>
+                      </a:solidFill>
+                      <a:prstDash val="solid"/>
+                      <a:round/>
+                      <a:headEnd type="none" w="med" len="med"/>
+                      <a:tailEnd type="none" w="med" len="med"/>
+                    </a:lnR>
+                    <a:lnT w="12700" cap="flat" cmpd="sng" algn="ctr">
+                      <a:solidFill>
+                        <a:srgbClr val="087D83"/>
+                      </a:solidFill>
+                      <a:prstDash val="solid"/>
+                      <a:round/>
+                      <a:headEnd type="none" w="med" len="med"/>
+                      <a:tailEnd type="none" w="med" len="med"/>
+                    </a:lnT>
+                    <a:lnB w="12700" cap="flat" cmpd="sng" algn="ctr">
+                      <a:solidFill>
+                        <a:srgbClr val="087D83"/>
+                      </a:solidFill>
+                      <a:prstDash val="solid"/>
+                      <a:round/>
+                      <a:headEnd type="none" w="med" len="med"/>
+                      <a:tailEnd type="none" w="med" len="med"/>
+                    </a:lnB>
+                  </a:tcPr>
+                </a:tc>
+              </a:tr>
+              <a:tr h="822960">
+                <a:tc>
+                  <a:txBody>
+                    <a:bodyPr/>
+                    <a:lstStyle/>
+                    <a:p>
+                      <a:pPr indent="0" marL="0">
+                        <a:buNone/>
+                      </a:pPr>
+                      <a:r>
+                        <a:rPr lang="en-US" sz="1600" dirty="0">
+                          <a:solidFill>
+                            <a:srgbClr val="173248"/>
+                          </a:solidFill>
+                          <a:latin typeface="Noto Sans CJK SC" pitchFamily="34" charset="0"/>
+                          <a:ea typeface="Noto Sans CJK SC" pitchFamily="34" charset="-122"/>
+                          <a:cs typeface="Noto Sans CJK SC" pitchFamily="34" charset="-120"/>
+                        </a:rPr>
+                        <a:t>跨公司收入排名</a:t>
+                      </a:r>
+                      <a:endParaRPr lang="en-US" sz="1600" dirty="0">
+                        <a:latin typeface="Noto Sans CJK SC" charset="0"/>
+                        <a:ea typeface="Noto Sans CJK SC" charset="0"/>
+                        <a:cs typeface="Noto Sans CJK SC" charset="0"/>
+                      </a:endParaRPr>
+                    </a:p>
+                  </a:txBody>
+                  <a:tcPr marL="36576" marR="36576" marT="36576" marB="36576">
+                    <a:lnL w="12700" cap="flat" cmpd="sng" algn="ctr">
+                      <a:solidFill>
+                        <a:srgbClr val="087D83"/>
+                      </a:solidFill>
+                      <a:prstDash val="solid"/>
+                      <a:round/>
+                      <a:headEnd type="none" w="med" len="med"/>
+                      <a:tailEnd type="none" w="med" len="med"/>
+                    </a:lnL>
+                    <a:lnR w="12700" cap="flat" cmpd="sng" algn="ctr">
+                      <a:solidFill>
+                        <a:srgbClr val="087D83"/>
+                      </a:solidFill>
+                      <a:prstDash val="solid"/>
+                      <a:round/>
+                      <a:headEnd type="none" w="med" len="med"/>
+                      <a:tailEnd type="none" w="med" len="med"/>
+                    </a:lnR>
+                    <a:lnT w="12700" cap="flat" cmpd="sng" algn="ctr">
+                      <a:solidFill>
+                        <a:srgbClr val="087D83"/>
+                      </a:solidFill>
+                      <a:prstDash val="solid"/>
+                      <a:round/>
+                      <a:headEnd type="none" w="med" len="med"/>
+                      <a:tailEnd type="none" w="med" len="med"/>
+                    </a:lnT>
+                    <a:lnB w="12700" cap="flat" cmpd="sng" algn="ctr">
+                      <a:solidFill>
+                        <a:srgbClr val="087D83"/>
+                      </a:solidFill>
+                      <a:prstDash val="solid"/>
+                      <a:round/>
+                      <a:headEnd type="none" w="med" len="med"/>
+                      <a:tailEnd type="none" w="med" len="med"/>
+                    </a:lnB>
+                  </a:tcPr>
+                </a:tc>
+                <a:tc>
+                  <a:txBody>
+                    <a:bodyPr/>
+                    <a:lstStyle/>
+                    <a:p>
+                      <a:pPr indent="0" marL="0">
+                        <a:buNone/>
+                      </a:pPr>
+                      <a:endParaRPr lang="en-US" sz="1600" dirty="0">
+                        <a:latin typeface="Noto Sans CJK SC" charset="0"/>
+                        <a:ea typeface="Noto Sans CJK SC" charset="0"/>
+                        <a:cs typeface="Noto Sans CJK SC" charset="0"/>
+                      </a:endParaRPr>
+                    </a:p>
+                  </a:txBody>
+                  <a:tcPr marL="36576" marR="36576" marT="36576" marB="36576">
+                    <a:lnL w="12700" cap="flat" cmpd="sng" algn="ctr">
+                      <a:solidFill>
+                        <a:srgbClr val="087D83"/>
+                      </a:solidFill>
+                      <a:prstDash val="solid"/>
+                      <a:round/>
+                      <a:headEnd type="none" w="med" len="med"/>
+                      <a:tailEnd type="none" w="med" len="med"/>
+                    </a:lnL>
+                    <a:lnR w="12700" cap="flat" cmpd="sng" algn="ctr">
+                      <a:solidFill>
+                        <a:srgbClr val="087D83"/>
+                      </a:solidFill>
+                      <a:prstDash val="solid"/>
+                      <a:round/>
+                      <a:headEnd type="none" w="med" len="med"/>
+                      <a:tailEnd type="none" w="med" len="med"/>
+                    </a:lnR>
+                    <a:lnT w="12700" cap="flat" cmpd="sng" algn="ctr">
+                      <a:solidFill>
+                        <a:srgbClr val="087D83"/>
+                      </a:solidFill>
+                      <a:prstDash val="solid"/>
+                      <a:round/>
+                      <a:headEnd type="none" w="med" len="med"/>
+                      <a:tailEnd type="none" w="med" len="med"/>
+                    </a:lnT>
+                    <a:lnB w="12700" cap="flat" cmpd="sng" algn="ctr">
+                      <a:solidFill>
+                        <a:srgbClr val="087D83"/>
+                      </a:solidFill>
+                      <a:prstDash val="solid"/>
+                      <a:round/>
+                      <a:headEnd type="none" w="med" len="med"/>
+                      <a:tailEnd type="none" w="med" len="med"/>
+                    </a:lnB>
+                  </a:tcPr>
+                </a:tc>
+                <a:tc>
+                  <a:txBody>
+                    <a:bodyPr/>
+                    <a:lstStyle/>
+                    <a:p>
+                      <a:pPr indent="0" marL="0">
+                        <a:buNone/>
+                      </a:pPr>
+                      <a:r>
+                        <a:rPr lang="en-US" sz="1600" dirty="0">
+                          <a:solidFill>
+                            <a:srgbClr val="173248"/>
+                          </a:solidFill>
+                          <a:latin typeface="Noto Sans CJK SC" pitchFamily="34" charset="0"/>
+                          <a:ea typeface="Noto Sans CJK SC" pitchFamily="34" charset="-122"/>
+                          <a:cs typeface="Noto Sans CJK SC" pitchFamily="34" charset="-120"/>
+                        </a:rPr>
+                        <a:t>换算不能消除口径差异</a:t>
+                      </a:r>
+                      <a:endParaRPr lang="en-US" sz="1600" dirty="0">
+                        <a:latin typeface="Noto Sans CJK SC" charset="0"/>
+                        <a:ea typeface="Noto Sans CJK SC" charset="0"/>
+                        <a:cs typeface="Noto Sans CJK SC" charset="0"/>
+                      </a:endParaRPr>
+                    </a:p>
+                  </a:txBody>
+                  <a:tcPr marL="36576" marR="36576" marT="36576" marB="36576">
+                    <a:lnL w="12700" cap="flat" cmpd="sng" algn="ctr">
+                      <a:solidFill>
+                        <a:srgbClr val="087D83"/>
+                      </a:solidFill>
+                      <a:prstDash val="solid"/>
+                      <a:round/>
+                      <a:headEnd type="none" w="med" len="med"/>
+                      <a:tailEnd type="none" w="med" len="med"/>
+                    </a:lnL>
+                    <a:lnR w="12700" cap="flat" cmpd="sng" algn="ctr">
+                      <a:solidFill>
+                        <a:srgbClr val="087D83"/>
+                      </a:solidFill>
+                      <a:prstDash val="solid"/>
+                      <a:round/>
+                      <a:headEnd type="none" w="med" len="med"/>
+                      <a:tailEnd type="none" w="med" len="med"/>
+                    </a:lnR>
+                    <a:lnT w="12700" cap="flat" cmpd="sng" algn="ctr">
+                      <a:solidFill>
+                        <a:srgbClr val="087D83"/>
+                      </a:solidFill>
+                      <a:prstDash val="solid"/>
+                      <a:round/>
+                      <a:headEnd type="none" w="med" len="med"/>
+                      <a:tailEnd type="none" w="med" len="med"/>
+                    </a:lnT>
+                    <a:lnB w="12700" cap="flat" cmpd="sng" algn="ctr">
+                      <a:solidFill>
+                        <a:srgbClr val="087D83"/>
+                      </a:solidFill>
+                      <a:prstDash val="solid"/>
+                      <a:round/>
+                      <a:headEnd type="none" w="med" len="med"/>
+                      <a:tailEnd type="none" w="med" len="med"/>
+                    </a:lnB>
+                  </a:tcPr>
+                </a:tc>
+              </a:tr>
+            </a:tbl>
+          </a:graphicData>
+        </a:graphic>
+      </p:graphicFrame>
+      <p:sp>
+        <p:nvSpPr>
+          <p:cNvPr id="5" name="footer"/>
           <p:cNvSpPr/>
           <p:nvPr/>
         </p:nvSpPr>

</xml_diff>

<commit_message>
Freeze Apple Toyota comparability benchmark materials
</commit_message>
<xml_diff>
--- a/docs/product/ppt-benchmark-materials/PPT-P0-08/p0-08-reference.pptx
+++ b/docs/product/ppt-benchmark-materials/PPT-P0-08/p0-08-reference.pptx
@@ -156,9 +156,9 @@
                 <a:pPr>
                   <a:defRPr b="0" i="0" strike="noStrike" sz="1200" u="none">
                     <a:solidFill>
-                      <a:srgbClr val="000000"/>
+                      <a:srgbClr val="173248"/>
                     </a:solidFill>
-                    <a:latin typeface="Arial"/>
+                    <a:latin typeface="Noto Sans CJK SC"/>
                   </a:defRPr>
                 </a:pPr>
               </a:p>
@@ -206,9 +206,9 @@
               <a:pPr>
                 <a:defRPr b="0" i="0" strike="noStrike" sz="1200" u="none">
                   <a:solidFill>
-                    <a:srgbClr val="000000"/>
+                    <a:srgbClr val="173248"/>
                   </a:solidFill>
-                  <a:latin typeface="Arial"/>
+                  <a:latin typeface="Noto Sans CJK SC"/>
                 </a:defRPr>
               </a:pPr>
             </a:p>
@@ -241,7 +241,7 @@
         <c:spPr>
           <a:ln w="12700" cap="flat">
             <a:solidFill>
-              <a:srgbClr val="888888"/>
+              <a:srgbClr val="173248"/>
             </a:solidFill>
             <a:prstDash val="solid"/>
             <a:round/>
@@ -254,7 +254,7 @@
             <a:pPr>
               <a:defRPr sz="1200" b="0" i="0" u="none" strike="noStrike">
                 <a:solidFill>
-                  <a:srgbClr val="000000"/>
+                  <a:srgbClr val="173248"/>
                 </a:solidFill>
                 <a:latin typeface="Noto Sans CJK SC"/>
               </a:defRPr>
@@ -280,7 +280,7 @@
           <c:spPr>
             <a:ln w="12700" cap="flat">
               <a:solidFill>
-                <a:srgbClr val="888888"/>
+                <a:srgbClr val="173248"/>
               </a:solidFill>
               <a:prstDash val="solid"/>
               <a:round/>
@@ -294,7 +294,7 @@
         <c:spPr>
           <a:ln w="12700" cap="flat">
             <a:solidFill>
-              <a:srgbClr val="888888"/>
+              <a:srgbClr val="173248"/>
             </a:solidFill>
             <a:prstDash val="solid"/>
             <a:round/>
@@ -307,7 +307,7 @@
             <a:pPr>
               <a:defRPr sz="1200" b="0" i="0" u="none" strike="noStrike">
                 <a:solidFill>
-                  <a:srgbClr val="000000"/>
+                  <a:srgbClr val="173248"/>
                 </a:solidFill>
                 <a:latin typeface="Noto Sans CJK SC"/>
               </a:defRPr>
@@ -320,7 +320,9 @@
         <c:crossBetween val="between"/>
       </c:valAx>
       <c:spPr>
-        <a:noFill/>
+        <a:solidFill>
+          <a:srgbClr val="FFFFFF"/>
+        </a:solidFill>
         <a:ln>
           <a:noFill/>
         </a:ln>
@@ -331,7 +333,9 @@
     <c:dispBlanksAs val="span"/>
   </c:chart>
   <c:spPr>
-    <a:noFill/>
+    <a:solidFill>
+      <a:srgbClr val="FFFFFF"/>
+    </a:solidFill>
     <a:ln>
       <a:noFill/>
     </a:ln>
@@ -364,7 +368,7 @@
               <c:strCache>
                 <c:ptCount val="1"/>
                 <c:pt idx="0">
-                  <c:v>Total sales and financial services revenue（百万日元）</c:v>
+                  <c:v>Total sales revenues (products and financial services)（百万日元）</c:v>
                 </c:pt>
               </c:strCache>
             </c:strRef>
@@ -385,9 +389,9 @@
                 <a:pPr>
                   <a:defRPr b="0" i="0" strike="noStrike" sz="1200" u="none">
                     <a:solidFill>
-                      <a:srgbClr val="000000"/>
+                      <a:srgbClr val="173248"/>
                     </a:solidFill>
-                    <a:latin typeface="Arial"/>
+                    <a:latin typeface="Noto Sans CJK SC"/>
                   </a:defRPr>
                 </a:pPr>
               </a:p>
@@ -407,7 +411,7 @@
                 <c:ptCount val="1"/>
                 <c:lvl>
                   <c:pt idx="0">
-                    <c:v>Sony Group Corporation</c:v>
+                    <c:v>Toyota Motor Corporation</c:v>
                   </c:pt>
                 </c:lvl>
               </c:multiLvlStrCache>
@@ -420,7 +424,7 @@
                 <c:formatCode>General</c:formatCode>
                 <c:ptCount val="1"/>
                 <c:pt idx="0">
-                  <c:v>13020768</c:v>
+                  <c:v>45095325</c:v>
                 </c:pt>
               </c:numCache>
             </c:numRef>
@@ -435,9 +439,9 @@
               <a:pPr>
                 <a:defRPr b="0" i="0" strike="noStrike" sz="1200" u="none">
                   <a:solidFill>
-                    <a:srgbClr val="000000"/>
+                    <a:srgbClr val="173248"/>
                   </a:solidFill>
-                  <a:latin typeface="Arial"/>
+                  <a:latin typeface="Noto Sans CJK SC"/>
                 </a:defRPr>
               </a:pPr>
             </a:p>
@@ -470,7 +474,7 @@
         <c:spPr>
           <a:ln w="12700" cap="flat">
             <a:solidFill>
-              <a:srgbClr val="888888"/>
+              <a:srgbClr val="173248"/>
             </a:solidFill>
             <a:prstDash val="solid"/>
             <a:round/>
@@ -483,7 +487,7 @@
             <a:pPr>
               <a:defRPr sz="1200" b="0" i="0" u="none" strike="noStrike">
                 <a:solidFill>
-                  <a:srgbClr val="000000"/>
+                  <a:srgbClr val="173248"/>
                 </a:solidFill>
                 <a:latin typeface="Noto Sans CJK SC"/>
               </a:defRPr>
@@ -509,7 +513,7 @@
           <c:spPr>
             <a:ln w="12700" cap="flat">
               <a:solidFill>
-                <a:srgbClr val="888888"/>
+                <a:srgbClr val="173248"/>
               </a:solidFill>
               <a:prstDash val="solid"/>
               <a:round/>
@@ -523,7 +527,7 @@
         <c:spPr>
           <a:ln w="12700" cap="flat">
             <a:solidFill>
-              <a:srgbClr val="888888"/>
+              <a:srgbClr val="173248"/>
             </a:solidFill>
             <a:prstDash val="solid"/>
             <a:round/>
@@ -536,7 +540,7 @@
             <a:pPr>
               <a:defRPr sz="1200" b="0" i="0" u="none" strike="noStrike">
                 <a:solidFill>
-                  <a:srgbClr val="000000"/>
+                  <a:srgbClr val="173248"/>
                 </a:solidFill>
                 <a:latin typeface="Noto Sans CJK SC"/>
               </a:defRPr>
@@ -549,7 +553,9 @@
         <c:crossBetween val="between"/>
       </c:valAx>
       <c:spPr>
-        <a:noFill/>
+        <a:solidFill>
+          <a:srgbClr val="FFFFFF"/>
+        </a:solidFill>
         <a:ln>
           <a:noFill/>
         </a:ln>
@@ -560,7 +566,9 @@
     <c:dispBlanksAs val="span"/>
   </c:chart>
   <c:spPr>
-    <a:noFill/>
+    <a:solidFill>
+      <a:srgbClr val="FFFFFF"/>
+    </a:solidFill>
     <a:ln>
       <a:noFill/>
     </a:ln>
@@ -968,7 +976,7 @@
             <a:r>
               <a:rPr lang="en-US" dirty="0"/>
               <a:t>跨公司收入可比性：先核对口径
-候选参考稿；Sony 官方 PDF 尚待下载，本稿未经财务审阅和 PowerPoint 宿主验收。
+候选参考稿；官方原件已冻结，本稿未经财务审阅和 PowerPoint 宿主验收。
 Attribution supplied by the input; source accuracy and license rights have not been independently verified.</a:t>
             </a:r>
             <a:endParaRPr lang="en-US" dirty="0"/>
@@ -1058,7 +1066,7 @@
             <a:r>
               <a:rPr lang="en-US" dirty="0"/>
               <a:t>资料时点与两份年度报告
-候选参考稿；Sony 官方 PDF 尚待下载，本稿未经财务审阅和 PowerPoint 宿主验收。
+候选参考稿；官方原件已冻结，本稿未经财务审阅和 PowerPoint 宿主验收。
 Attribution supplied by the input; source accuracy and license rights have not been independently verified.</a:t>
             </a:r>
             <a:endParaRPr lang="en-US" dirty="0"/>
@@ -1148,7 +1156,7 @@
             <a:r>
               <a:rPr lang="en-US" dirty="0"/>
               <a:t>财年、准则、币种和范围矩阵
-候选参考稿；Sony 官方 PDF 尚待下载，本稿未经财务审阅和 PowerPoint 宿主验收。
+候选参考稿；官方原件已冻结，本稿未经财务审阅和 PowerPoint 宿主验收。
 Attribution supplied by the input; source accuracy and license rights have not been independently verified.</a:t>
             </a:r>
             <a:endParaRPr lang="en-US" dirty="0"/>
@@ -1238,7 +1246,7 @@
             <a:r>
               <a:rPr lang="en-US" dirty="0"/>
               <a:t>Apple：原币净销售额
-候选参考稿；Sony 官方 PDF 尚待下载，本稿未经财务审阅和 PowerPoint 宿主验收。
+候选参考稿；官方原件已冻结，本稿未经财务审阅和 PowerPoint 宿主验收。
 [apple-sales] https://www.sec.gov/Archives/edgar/data/320193/000032019324000123/aapl-20240928.htm · PDF 第 32 页
 Apple 净销售额 391035 百万美元
 Attribution supplied by the input; source accuracy and license rights have not been independently verified.</a:t>
@@ -1329,10 +1337,10 @@
           <a:p>
             <a:r>
               <a:rPr lang="en-US" dirty="0"/>
-              <a:t>Sony：原币销售及金融服务收入
-候选参考稿；Sony 官方 PDF 尚待下载，本稿未经财务审阅和 PowerPoint 宿主验收。
-[sony-sales] https://www.sony.com/en/SonyInfo/IR/library/FY2023_20F_PDF.pdf · PDF 第 48 页
-Sony 销售及金融服务收入 13020768 百万日元
+              <a:t>Toyota：原币销售及金融服务收入
+候选参考稿；官方原件已冻结，本稿未经财务审阅和 PowerPoint 宿主验收。
+[toyota-sales] https://global.toyota/pages/global_toyota/ir/library/sec/20-F_202403_final.pdf · PDF 第 167 页
+Toyota 销售及金融服务收入 45095325 百万日元
 Attribution supplied by the input; source accuracy and license rights have not been independently verified.</a:t>
             </a:r>
             <a:endParaRPr lang="en-US" dirty="0"/>
@@ -1421,8 +1429,8 @@
           <a:p>
             <a:r>
               <a:rPr lang="en-US" dirty="0"/>
-              <a:t>Sony 汇率换算仅作示意
-候选参考稿；Sony 官方 PDF 尚待下载，本稿未经财务审阅和 PowerPoint 宿主验收。
+              <a:t>Toyota 汇率换算仅作示意
+候选参考稿；官方原件已冻结，本稿未经财务审阅和 PowerPoint 宿主验收。
 Attribution supplied by the input; source accuracy and license rights have not been independently verified.</a:t>
             </a:r>
             <a:endParaRPr lang="en-US" dirty="0"/>
@@ -1512,7 +1520,7 @@
             <a:r>
               <a:rPr lang="en-US" dirty="0"/>
               <a:t>不可比项与留空规则
-候选参考稿；Sony 官方 PDF 尚待下载，本稿未经财务审阅和 PowerPoint 宿主验收。
+候选参考稿；官方原件已冻结，本稿未经财务审阅和 PowerPoint 宿主验收。
 Attribution supplied by the input; source accuracy and license rights have not been independently verified.</a:t>
             </a:r>
             <a:endParaRPr lang="en-US" dirty="0"/>
@@ -1602,7 +1610,7 @@
             <a:r>
               <a:rPr lang="en-US" dirty="0"/>
               <a:t>结论、审阅和宿主验收
-候选参考稿；Sony 官方 PDF 尚待下载，本稿未经财务审阅和 PowerPoint 宿主验收。
+候选参考稿；官方原件已冻结，本稿未经财务审阅和 PowerPoint 宿主验收。
 Attribution supplied by the input; source accuracy and license rights have not been independently verified.</a:t>
             </a:r>
             <a:endParaRPr lang="en-US" dirty="0"/>
@@ -2197,7 +2205,7 @@
                 <a:ea typeface="Noto Sans CJK SC" pitchFamily="34" charset="-122"/>
                 <a:cs typeface="Noto Sans CJK SC" pitchFamily="34" charset="-120"/>
               </a:rPr>
-              <a:t>as-of 2024-11-01。Apple FY2024 为 Form 10-K；Sony FY2023 为 Form 20-F。Sony PDF 原件尚待本地冻结。</a:t>
+              <a:t>as-of 2024-11-01。Apple 10-K 于 2024-11-01 披露；Toyota 20-F 于 2024-06-25 披露，汇率汇总于 2024-05-08 发布。</a:t>
             </a:r>
             <a:endParaRPr lang="en-US" sz="1800" dirty="0"/>
           </a:p>
@@ -2346,7 +2354,7 @@
                 <a:ea typeface="Noto Sans CJK SC" pitchFamily="34" charset="-122"/>
                 <a:cs typeface="Noto Sans CJK SC" pitchFamily="34" charset="-120"/>
               </a:rPr>
-              <a:t>Apple：2024-09-28 / US GAAP / 百万美元 / 净销售额。Sony：2024-03-31 / IFRS / 百万日元 / 销售及金融服务收入。</a:t>
+              <a:t>Apple：2024-09-28 / US GAAP / 百万美元 / 净销售额。Toyota：2024-03-31 / IFRS / 百万日元 / 销售及金融服务收入。</a:t>
             </a:r>
             <a:endParaRPr lang="en-US" sz="1800" dirty="0"/>
           </a:p>
@@ -2527,7 +2535,7 @@
                           <a:ea typeface="Noto Sans CJK SC" pitchFamily="34" charset="-122"/>
                           <a:cs typeface="Noto Sans CJK SC" pitchFamily="34" charset="-120"/>
                         </a:rPr>
-                        <a:t>Sony FY2023</a:t>
+                        <a:t>Toyota FY2024</a:t>
                       </a:r>
                       <a:endParaRPr lang="en-US" sz="1500" dirty="0">
                         <a:latin typeface="Noto Sans CJK SC" charset="0"/>
@@ -3315,7 +3323,7 @@
                           <a:ea typeface="Noto Sans CJK SC" pitchFamily="34" charset="-122"/>
                           <a:cs typeface="Noto Sans CJK SC" pitchFamily="34" charset="-120"/>
                         </a:rPr>
-                        <a:t>Total sales and financial services revenue</a:t>
+                        <a:t>Total sales revenues (products and financial services)</a:t>
                       </a:r>
                       <a:endParaRPr lang="en-US" sz="1500" dirty="0">
                         <a:latin typeface="Noto Sans CJK SC" charset="0"/>
@@ -3511,7 +3519,7 @@
                 <a:ea typeface="Noto Sans CJK SC" pitchFamily="34" charset="-122"/>
                 <a:cs typeface="Noto Sans CJK SC" pitchFamily="34" charset="-120"/>
               </a:rPr>
-              <a:t>391,035 百万美元；Apple 2024 Form 10-K，PDF 第 32 页。不得与 Sony 原币图共用数值轴。</a:t>
+              <a:t>391,035 百万美元；Apple 2024 Form 10-K，PDF 第 32 页。不得与 Toyota 原币图共用数值轴。</a:t>
             </a:r>
             <a:endParaRPr lang="en-US" sz="1800" dirty="0"/>
           </a:p>
@@ -3590,10 +3598,10 @@
           <a:ln/>
         </p:spPr>
         <p:txBody>
-          <a:bodyPr wrap="square" lIns="0" tIns="0" rIns="0" bIns="0" rtlCol="0" anchor="ctr"/>
+          <a:bodyPr wrap="square" lIns="0" tIns="0" rIns="0" bIns="0" rtlCol="0" anchor="t"/>
           <a:lstStyle/>
           <a:p>
-            <a:pPr indent="0" marL="0">
+            <a:pPr algn="l" indent="0" marL="0">
               <a:buNone/>
             </a:pPr>
             <a:r>
@@ -3676,7 +3684,7 @@
                 <a:ea typeface="Noto Sans CJK SC" pitchFamily="34" charset="-122"/>
                 <a:cs typeface="Noto Sans CJK SC" pitchFamily="34" charset="-120"/>
               </a:rPr>
-              <a:t>Sony：原币销售及金融服务收入</a:t>
+              <a:t>Toyota：原币销售及金融服务收入</a:t>
             </a:r>
             <a:endParaRPr lang="en-US" sz="2600" dirty="0"/>
           </a:p>
@@ -3715,7 +3723,7 @@
                 <a:ea typeface="Noto Sans CJK SC" pitchFamily="34" charset="-122"/>
                 <a:cs typeface="Noto Sans CJK SC" pitchFamily="34" charset="-120"/>
               </a:rPr>
-              <a:t>13,020,768 百万日元；Sony Form 20-F，PDF 第 48 页。包括金融服务收入。</a:t>
+              <a:t>45,095,325 百万日元；Toyota Form 20-F，PDF 第 167 页。包括金融服务收入。</a:t>
             </a:r>
             <a:endParaRPr lang="en-US" sz="1800" dirty="0"/>
           </a:p>
@@ -3723,7 +3731,7 @@
       </p:sp>
       <p:graphicFrame>
         <p:nvGraphicFramePr>
-          <p:cNvPr id="4" name="sony-native-chart" descr=""/>
+          <p:cNvPr id="4" name="toyota-native-chart" descr=""/>
           <p:cNvGraphicFramePr/>
           <p:nvPr/>
         </p:nvGraphicFramePr>
@@ -3770,7 +3778,7 @@
                 <a:ea typeface="Noto Sans CJK SC" pitchFamily="34" charset="-122"/>
                 <a:cs typeface="Noto Sans CJK SC" pitchFamily="34" charset="-120"/>
               </a:rPr>
-              <a:t>来源：Sony FY2023 Form 20-F，PDF 第 48 页；原件待冻结</a:t>
+              <a:t>来源：Toyota FY2024 Form 20-F，PDF 第 167 页；原件已冻结</a:t>
             </a:r>
             <a:endParaRPr lang="en-US" sz="900" dirty="0"/>
           </a:p>
@@ -3794,10 +3802,10 @@
           <a:ln/>
         </p:spPr>
         <p:txBody>
-          <a:bodyPr wrap="square" lIns="0" tIns="0" rIns="0" bIns="0" rtlCol="0" anchor="ctr"/>
+          <a:bodyPr wrap="square" lIns="0" tIns="0" rIns="0" bIns="0" rtlCol="0" anchor="t"/>
           <a:lstStyle/>
           <a:p>
-            <a:pPr indent="0" marL="0">
+            <a:pPr algn="l" indent="0" marL="0">
               <a:buNone/>
             </a:pPr>
             <a:r>
@@ -3809,7 +3817,7 @@
                 <a:ea typeface="Noto Sans CJK SC" pitchFamily="34" charset="-122"/>
                 <a:cs typeface="Noto Sans CJK SC" pitchFamily="34" charset="-120"/>
               </a:rPr>
-              <a:t>[sony-sales] https://www.sony.com/en/SonyInfo/IR/library/FY2023_20F_PDF.pdf · PDF 第 48 页</a:t>
+              <a:t>[toyota-sales] https://global.toyota/pages/global_toyota/ir/library/sec/20-F_202403_final.pdf · PDF 第 167 页</a:t>
             </a:r>
             <a:endParaRPr lang="en-US" sz="800" dirty="0"/>
           </a:p>
@@ -3880,7 +3888,7 @@
                 <a:ea typeface="Noto Sans CJK SC" pitchFamily="34" charset="-122"/>
                 <a:cs typeface="Noto Sans CJK SC" pitchFamily="34" charset="-120"/>
               </a:rPr>
-              <a:t>Sony 汇率换算仅作示意</a:t>
+              <a:t>Toyota 汇率换算仅作示意</a:t>
             </a:r>
             <a:endParaRPr lang="en-US" sz="2600" dirty="0"/>
           </a:p>
@@ -3919,7 +3927,7 @@
                 <a:ea typeface="Noto Sans CJK SC" pitchFamily="34" charset="-122"/>
                 <a:cs typeface="Noto Sans CJK SC" pitchFamily="34" charset="-120"/>
               </a:rPr>
-              <a:t>13,020,768 ÷ 144.4 = 90,171.52 百万美元。汇率为 Sony FY2023 年平均，官方报表第 24 页。</a:t>
+              <a:t>45,095,325 ÷ 145 = 311,002.24 百万美元。汇率取 Toyota FY2024 历史 12 个月栏，官方汇总 PDF 第 28 页；不是 FY2025 预测栏。</a:t>
             </a:r>
             <a:endParaRPr lang="en-US" sz="1800" dirty="0"/>
           </a:p>
@@ -4076,7 +4084,7 @@
       </p:sp>
       <p:graphicFrame>
         <p:nvGraphicFramePr>
-          <p:cNvPr id="8" name="comparison-gaps"/>
+          <p:cNvPr id="4" name="comparison-gaps"/>
           <p:cNvGraphicFramePr>
             <a:graphicFrameLocks noGrp="1"/>
           </p:cNvGraphicFramePr>
@@ -4817,7 +4825,7 @@
                 <a:ea typeface="Noto Sans CJK SC" pitchFamily="34" charset="-122"/>
                 <a:cs typeface="Noto Sans CJK SC" pitchFamily="34" charset="-120"/>
               </a:rPr>
-              <a:t>保留原币、原期间和原始口径；示意换算不支持相对规模结论。待 Sony 原件、本地摘要、财务审阅及真实 PowerPoint 重开编辑证据。</a:t>
+              <a:t>保留原币、原期间和原始口径；示意换算不支持相对规模结论。官方原件及本地摘要已冻结；仍待财务审阅及真实 PowerPoint 重开编辑证据。</a:t>
             </a:r>
             <a:endParaRPr lang="en-US" sz="1800" dirty="0"/>
           </a:p>

</xml_diff>

<commit_message>
Add source-backed P0-08 finance comparability production bundle
</commit_message>
<xml_diff>
--- a/docs/product/ppt-benchmark-materials/PPT-P0-08/p0-08-reference.pptx
+++ b/docs/product/ppt-benchmark-materials/PPT-P0-08/p0-08-reference.pptx
@@ -148,7 +148,7 @@
           </c:spPr>
           <c:invertIfNegative val="0"/>
           <c:dLbls>
-            <c:numFmt formatCode="#,##0" sourceLinked="0"/>
+            <c:numFmt formatCode="#,##0.########" sourceLinked="0"/>
             <c:txPr>
               <a:bodyPr/>
               <a:lstStyle/>
@@ -198,7 +198,7 @@
           </c:val>
         </c:ser>
         <c:dLbls>
-          <c:numFmt formatCode="#,##0" sourceLinked="0"/>
+          <c:numFmt formatCode="#,##0.########" sourceLinked="0"/>
           <c:txPr>
             <a:bodyPr/>
             <a:lstStyle/>
@@ -381,7 +381,7 @@
           </c:spPr>
           <c:invertIfNegative val="0"/>
           <c:dLbls>
-            <c:numFmt formatCode="#,##0" sourceLinked="0"/>
+            <c:numFmt formatCode="#,##0.########" sourceLinked="0"/>
             <c:txPr>
               <a:bodyPr/>
               <a:lstStyle/>
@@ -431,7 +431,7 @@
           </c:val>
         </c:ser>
         <c:dLbls>
-          <c:numFmt formatCode="#,##0" sourceLinked="0"/>
+          <c:numFmt formatCode="#,##0.########" sourceLinked="0"/>
           <c:txPr>
             <a:bodyPr/>
             <a:lstStyle/>
@@ -1067,6 +1067,10 @@
               <a:rPr lang="en-US" dirty="0"/>
               <a:t>资料时点与两份年度报告
 候选参考稿；官方原件已冻结，本稿未经财务审阅和 PowerPoint 宿主验收。
+[apple-sales] https://www.sec.gov/Archives/edgar/data/320193/000032019324000123/aapl-20240928.htm ; local:basis.json · PDF 32 ; companies.apple.valueMillions
+Apple FY2024 净销售额为 391,035 百万美元。
+[toyota-sales] https://global.toyota/pages/global_toyota/ir/library/sec/20-F_202403_final.pdf ; https://global.toyota/pages/global_toyota/ir/library/sec/20-F_202403_final.pdf ; local:basis.json · PDF 167 ; PDF 167 ; companies.toyota.valueMillions
+Toyota FY2024 销售收入为 45,095,325 百万日元，含金融服务收入。
 Attribution supplied by the input; source accuracy and license rights have not been independently verified.</a:t>
             </a:r>
             <a:endParaRPr lang="en-US" dirty="0"/>
@@ -1157,6 +1161,10 @@
               <a:rPr lang="en-US" dirty="0"/>
               <a:t>财年、准则、币种和范围矩阵
 候选参考稿；官方原件已冻结，本稿未经财务审阅和 PowerPoint 宿主验收。
+[apple-sales] https://www.sec.gov/Archives/edgar/data/320193/000032019324000123/aapl-20240928.htm ; local:basis.json · PDF 32 ; companies.apple.valueMillions
+Apple FY2024 净销售额为 391,035 百万美元。
+[toyota-sales] https://global.toyota/pages/global_toyota/ir/library/sec/20-F_202403_final.pdf ; https://global.toyota/pages/global_toyota/ir/library/sec/20-F_202403_final.pdf ; local:basis.json · PDF 167 ; PDF 167 ; companies.toyota.valueMillions
+Toyota FY2024 销售收入为 45,095,325 百万日元，含金融服务收入。
 Attribution supplied by the input; source accuracy and license rights have not been independently verified.</a:t>
             </a:r>
             <a:endParaRPr lang="en-US" dirty="0"/>
@@ -1247,8 +1255,8 @@
               <a:rPr lang="en-US" dirty="0"/>
               <a:t>Apple：原币净销售额
 候选参考稿；官方原件已冻结，本稿未经财务审阅和 PowerPoint 宿主验收。
-[apple-sales] https://www.sec.gov/Archives/edgar/data/320193/000032019324000123/aapl-20240928.htm · PDF 第 32 页
-Apple 净销售额 391035 百万美元
+[apple-sales] https://www.sec.gov/Archives/edgar/data/320193/000032019324000123/aapl-20240928.htm ; local:basis.json · PDF 32 ; companies.apple.valueMillions
+Apple FY2024 净销售额为 391,035 百万美元。
 Attribution supplied by the input; source accuracy and license rights have not been independently verified.</a:t>
             </a:r>
             <a:endParaRPr lang="en-US" dirty="0"/>
@@ -1339,8 +1347,8 @@
               <a:rPr lang="en-US" dirty="0"/>
               <a:t>Toyota：原币销售及金融服务收入
 候选参考稿；官方原件已冻结，本稿未经财务审阅和 PowerPoint 宿主验收。
-[toyota-sales] https://global.toyota/pages/global_toyota/ir/library/sec/20-F_202403_final.pdf · PDF 第 167 页
-Toyota 销售及金融服务收入 45095325 百万日元
+[toyota-sales] https://global.toyota/pages/global_toyota/ir/library/sec/20-F_202403_final.pdf ; https://global.toyota/pages/global_toyota/ir/library/sec/20-F_202403_final.pdf ; local:basis.json · PDF 167 ; PDF 167 ; companies.toyota.valueMillions
+Toyota FY2024 销售收入为 45,095,325 百万日元，含金融服务收入。
 Attribution supplied by the input; source accuracy and license rights have not been independently verified.</a:t>
             </a:r>
             <a:endParaRPr lang="en-US" dirty="0"/>
@@ -1431,6 +1439,10 @@
               <a:rPr lang="en-US" dirty="0"/>
               <a:t>Toyota 汇率换算仅作示意
 候选参考稿；官方原件已冻结，本稿未经财务审阅和 PowerPoint 宿主验收。
+[fx-period] https://global.toyota/pages/global_toyota/ir/financial-results/2024_4q_summary_en.pdf · PDF 28 FY2024 12 months
+Toyota 官方汇总的 FY2024 已发生十二个月栏使用 1 美元兑 145 日元；右侧 FY2025 预测栏不能充当历史依据。
+[fx-illustrative] https://global.toyota/pages/global_toyota/ir/library/sec/20-F_202403_final.pdf ; https://global.toyota/pages/global_toyota/ir/financial-results/2024_4q_summary_en.pdf ; local:independent-recalc.csv · PDF 167 ; PDF 28 FY2024 12 months ; CSV toyota_total_sales_revenues
+Toyota 收入按其 FY2024 历史汇率示意换算为 311,002.24 百万美元。
 Attribution supplied by the input; source accuracy and license rights have not been independently verified.</a:t>
             </a:r>
             <a:endParaRPr lang="en-US" dirty="0"/>
@@ -1521,6 +1533,8 @@
               <a:rPr lang="en-US" dirty="0"/>
               <a:t>不可比项与留空规则
 候选参考稿；官方原件已冻结，本稿未经财务审阅和 PowerPoint 宿主验收。
+[comparison-gap] https://www.sec.gov/Archives/edgar/data/320193/000032019324000123/aapl-20240928.htm ; https://global.toyota/pages/global_toyota/ir/library/sec/20-F_202403_final.pdf ; https://global.toyota/pages/global_toyota/ir/library/sec/20-F_202403_final.pdf · PDF 32 ; PDF 167 ; PDF 167
+两公司财年结束日、会计准则和收入范围不同；同口径美元差额与跨公司收入排名均须留空。
 Attribution supplied by the input; source accuracy and license rights have not been independently verified.</a:t>
             </a:r>
             <a:endParaRPr lang="en-US" dirty="0"/>
@@ -1611,6 +1625,8 @@
               <a:rPr lang="en-US" dirty="0"/>
               <a:t>结论、审阅和宿主验收
 候选参考稿；官方原件已冻结，本稿未经财务审阅和 PowerPoint 宿主验收。
+[comparison-gap] https://www.sec.gov/Archives/edgar/data/320193/000032019324000123/aapl-20240928.htm ; https://global.toyota/pages/global_toyota/ir/library/sec/20-F_202403_final.pdf ; https://global.toyota/pages/global_toyota/ir/library/sec/20-F_202403_final.pdf · PDF 32 ; PDF 167 ; PDF 167
+两公司财年结束日、会计准则和收入范围不同；同口径美元差额与跨公司收入排名均须留空。
 Attribution supplied by the input; source accuracy and license rights have not been independently verified.</a:t>
             </a:r>
             <a:endParaRPr lang="en-US" dirty="0"/>
@@ -2070,7 +2086,7 @@
         </p:nvSpPr>
         <p:spPr>
           <a:xfrm>
-            <a:off x="822960" y="6355080"/>
+            <a:off x="822960" y="6053328"/>
             <a:ext cx="10424160" cy="228600"/>
           </a:xfrm>
           <a:prstGeom prst="rect">
@@ -2219,7 +2235,7 @@
         </p:nvSpPr>
         <p:spPr>
           <a:xfrm>
-            <a:off x="822960" y="6355080"/>
+            <a:off x="822960" y="6053328"/>
             <a:ext cx="10424160" cy="228600"/>
           </a:xfrm>
           <a:prstGeom prst="rect">
@@ -2247,6 +2263,45 @@
               <a:t>参考稿；资料与专业结论待审阅</a:t>
             </a:r>
             <a:endParaRPr lang="en-US" sz="900" dirty="0"/>
+          </a:p>
+        </p:txBody>
+      </p:sp>
+      <p:sp>
+        <p:nvSpPr>
+          <p:cNvPr id="5" name="source-attribution"/>
+          <p:cNvSpPr/>
+          <p:nvPr/>
+        </p:nvSpPr>
+        <p:spPr>
+          <a:xfrm>
+            <a:off x="457200" y="6446520"/>
+            <a:ext cx="11247120" cy="274320"/>
+          </a:xfrm>
+          <a:prstGeom prst="rect">
+            <a:avLst/>
+          </a:prstGeom>
+          <a:noFill/>
+          <a:ln/>
+        </p:spPr>
+        <p:txBody>
+          <a:bodyPr wrap="square" lIns="0" tIns="0" rIns="0" bIns="0" rtlCol="0" anchor="t"/>
+          <a:lstStyle/>
+          <a:p>
+            <a:pPr algn="l" indent="0" marL="0">
+              <a:buNone/>
+            </a:pPr>
+            <a:r>
+              <a:rPr lang="en-US" sz="800" dirty="0">
+                <a:solidFill>
+                  <a:srgbClr val="173248"/>
+                </a:solidFill>
+                <a:latin typeface="Noto Sans CJK SC" pitchFamily="34" charset="0"/>
+                <a:ea typeface="Noto Sans CJK SC" pitchFamily="34" charset="-122"/>
+                <a:cs typeface="Noto Sans CJK SC" pitchFamily="34" charset="-120"/>
+              </a:rPr>
+              <a:t>[apple-sales] https://www.sec.gov/Archives/edgar/data/320193/000032019324000123/aapl-20240928.htm ; local:basis.json · PDF 32 ; companies.apple.valueMillions；[toyota-sales] https://global.toyota/pages/global_toyota/ir/library/sec/20-F_202403_final.pdf ; https://global.toyota/pages/global_toyota/ir/library/sec/20-F_202403_final.pdf ; local:basis.json · PDF 167 ; PDF 167 ; companies.toyota.valueMillions</a:t>
+            </a:r>
+            <a:endParaRPr lang="en-US" sz="800" dirty="0"/>
           </a:p>
         </p:txBody>
       </p:sp>
@@ -3384,7 +3439,7 @@
         </p:nvSpPr>
         <p:spPr>
           <a:xfrm>
-            <a:off x="822960" y="6355080"/>
+            <a:off x="822960" y="6053328"/>
             <a:ext cx="10424160" cy="228600"/>
           </a:xfrm>
           <a:prstGeom prst="rect">
@@ -3412,6 +3467,45 @@
               <a:t>参考稿；资料与专业结论待审阅</a:t>
             </a:r>
             <a:endParaRPr lang="en-US" sz="900" dirty="0"/>
+          </a:p>
+        </p:txBody>
+      </p:sp>
+      <p:sp>
+        <p:nvSpPr>
+          <p:cNvPr id="6" name="source-attribution"/>
+          <p:cNvSpPr/>
+          <p:nvPr/>
+        </p:nvSpPr>
+        <p:spPr>
+          <a:xfrm>
+            <a:off x="457200" y="6446520"/>
+            <a:ext cx="11247120" cy="274320"/>
+          </a:xfrm>
+          <a:prstGeom prst="rect">
+            <a:avLst/>
+          </a:prstGeom>
+          <a:noFill/>
+          <a:ln/>
+        </p:spPr>
+        <p:txBody>
+          <a:bodyPr wrap="square" lIns="0" tIns="0" rIns="0" bIns="0" rtlCol="0" anchor="t"/>
+          <a:lstStyle/>
+          <a:p>
+            <a:pPr algn="l" indent="0" marL="0">
+              <a:buNone/>
+            </a:pPr>
+            <a:r>
+              <a:rPr lang="en-US" sz="800" dirty="0">
+                <a:solidFill>
+                  <a:srgbClr val="173248"/>
+                </a:solidFill>
+                <a:latin typeface="Noto Sans CJK SC" pitchFamily="34" charset="0"/>
+                <a:ea typeface="Noto Sans CJK SC" pitchFamily="34" charset="-122"/>
+                <a:cs typeface="Noto Sans CJK SC" pitchFamily="34" charset="-120"/>
+              </a:rPr>
+              <a:t>[apple-sales] https://www.sec.gov/Archives/edgar/data/320193/000032019324000123/aapl-20240928.htm ; local:basis.json · PDF 32 ; companies.apple.valueMillions；[toyota-sales] https://global.toyota/pages/global_toyota/ir/library/sec/20-F_202403_final.pdf ; https://global.toyota/pages/global_toyota/ir/library/sec/20-F_202403_final.pdf ; local:basis.json · PDF 167 ; PDF 167 ; companies.toyota.valueMillions</a:t>
+            </a:r>
+            <a:endParaRPr lang="en-US" sz="800" dirty="0"/>
           </a:p>
         </p:txBody>
       </p:sp>
@@ -3549,7 +3643,7 @@
         </p:nvSpPr>
         <p:spPr>
           <a:xfrm>
-            <a:off x="822960" y="6355080"/>
+            <a:off x="822960" y="6053328"/>
             <a:ext cx="10424160" cy="228600"/>
           </a:xfrm>
           <a:prstGeom prst="rect">
@@ -3613,7 +3707,7 @@
                 <a:ea typeface="Noto Sans CJK SC" pitchFamily="34" charset="-122"/>
                 <a:cs typeface="Noto Sans CJK SC" pitchFamily="34" charset="-120"/>
               </a:rPr>
-              <a:t>[apple-sales] https://www.sec.gov/Archives/edgar/data/320193/000032019324000123/aapl-20240928.htm · PDF 第 32 页</a:t>
+              <a:t>[apple-sales] https://www.sec.gov/Archives/edgar/data/320193/000032019324000123/aapl-20240928.htm ; local:basis.json · PDF 32 ; companies.apple.valueMillions</a:t>
             </a:r>
             <a:endParaRPr lang="en-US" sz="800" dirty="0"/>
           </a:p>
@@ -3753,7 +3847,7 @@
         </p:nvSpPr>
         <p:spPr>
           <a:xfrm>
-            <a:off x="822960" y="6355080"/>
+            <a:off x="822960" y="6053328"/>
             <a:ext cx="10424160" cy="228600"/>
           </a:xfrm>
           <a:prstGeom prst="rect">
@@ -3817,7 +3911,7 @@
                 <a:ea typeface="Noto Sans CJK SC" pitchFamily="34" charset="-122"/>
                 <a:cs typeface="Noto Sans CJK SC" pitchFamily="34" charset="-120"/>
               </a:rPr>
-              <a:t>[toyota-sales] https://global.toyota/pages/global_toyota/ir/library/sec/20-F_202403_final.pdf · PDF 第 167 页</a:t>
+              <a:t>[toyota-sales] https://global.toyota/pages/global_toyota/ir/library/sec/20-F_202403_final.pdf ; https://global.toyota/pages/global_toyota/ir/library/sec/20-F_202403_final.pdf ; local:basis.json · PDF 167 ; PDF 167 ; companies.toyota.valueMillions</a:t>
             </a:r>
             <a:endParaRPr lang="en-US" sz="800" dirty="0"/>
           </a:p>
@@ -3941,7 +4035,7 @@
         </p:nvSpPr>
         <p:spPr>
           <a:xfrm>
-            <a:off x="822960" y="6355080"/>
+            <a:off x="822960" y="6053328"/>
             <a:ext cx="10424160" cy="228600"/>
           </a:xfrm>
           <a:prstGeom prst="rect">
@@ -3969,6 +4063,45 @@
               <a:t>参考稿；资料与专业结论待审阅</a:t>
             </a:r>
             <a:endParaRPr lang="en-US" sz="900" dirty="0"/>
+          </a:p>
+        </p:txBody>
+      </p:sp>
+      <p:sp>
+        <p:nvSpPr>
+          <p:cNvPr id="5" name="source-attribution"/>
+          <p:cNvSpPr/>
+          <p:nvPr/>
+        </p:nvSpPr>
+        <p:spPr>
+          <a:xfrm>
+            <a:off x="457200" y="6446520"/>
+            <a:ext cx="11247120" cy="274320"/>
+          </a:xfrm>
+          <a:prstGeom prst="rect">
+            <a:avLst/>
+          </a:prstGeom>
+          <a:noFill/>
+          <a:ln/>
+        </p:spPr>
+        <p:txBody>
+          <a:bodyPr wrap="square" lIns="0" tIns="0" rIns="0" bIns="0" rtlCol="0" anchor="t"/>
+          <a:lstStyle/>
+          <a:p>
+            <a:pPr algn="l" indent="0" marL="0">
+              <a:buNone/>
+            </a:pPr>
+            <a:r>
+              <a:rPr lang="en-US" sz="800" dirty="0">
+                <a:solidFill>
+                  <a:srgbClr val="173248"/>
+                </a:solidFill>
+                <a:latin typeface="Noto Sans CJK SC" pitchFamily="34" charset="0"/>
+                <a:ea typeface="Noto Sans CJK SC" pitchFamily="34" charset="-122"/>
+                <a:cs typeface="Noto Sans CJK SC" pitchFamily="34" charset="-120"/>
+              </a:rPr>
+              <a:t>[fx-period] https://global.toyota/pages/global_toyota/ir/financial-results/2024_4q_summary_en.pdf · PDF 28 FY2024 12 months；[fx-illustrative] https://global.toyota/pages/global_toyota/ir/library/sec/20-F_202403_final.pdf ; https://global.toyota/pages/global_toyota/ir/financial-results/2024_4q_summary_en.pdf ; local:independent-recalc.csv · PDF 167 ; PDF 28 FY2024 12 months ; CSV toyota_total_sales_revenues</a:t>
+            </a:r>
+            <a:endParaRPr lang="en-US" sz="800" dirty="0"/>
           </a:p>
         </p:txBody>
       </p:sp>
@@ -4690,7 +4823,7 @@
         </p:nvSpPr>
         <p:spPr>
           <a:xfrm>
-            <a:off x="822960" y="6355080"/>
+            <a:off x="822960" y="6053328"/>
             <a:ext cx="10424160" cy="228600"/>
           </a:xfrm>
           <a:prstGeom prst="rect">
@@ -4718,6 +4851,45 @@
               <a:t>参考稿；资料与专业结论待审阅</a:t>
             </a:r>
             <a:endParaRPr lang="en-US" sz="900" dirty="0"/>
+          </a:p>
+        </p:txBody>
+      </p:sp>
+      <p:sp>
+        <p:nvSpPr>
+          <p:cNvPr id="6" name="source-attribution"/>
+          <p:cNvSpPr/>
+          <p:nvPr/>
+        </p:nvSpPr>
+        <p:spPr>
+          <a:xfrm>
+            <a:off x="457200" y="6446520"/>
+            <a:ext cx="11247120" cy="274320"/>
+          </a:xfrm>
+          <a:prstGeom prst="rect">
+            <a:avLst/>
+          </a:prstGeom>
+          <a:noFill/>
+          <a:ln/>
+        </p:spPr>
+        <p:txBody>
+          <a:bodyPr wrap="square" lIns="0" tIns="0" rIns="0" bIns="0" rtlCol="0" anchor="t"/>
+          <a:lstStyle/>
+          <a:p>
+            <a:pPr algn="l" indent="0" marL="0">
+              <a:buNone/>
+            </a:pPr>
+            <a:r>
+              <a:rPr lang="en-US" sz="800" dirty="0">
+                <a:solidFill>
+                  <a:srgbClr val="173248"/>
+                </a:solidFill>
+                <a:latin typeface="Noto Sans CJK SC" pitchFamily="34" charset="0"/>
+                <a:ea typeface="Noto Sans CJK SC" pitchFamily="34" charset="-122"/>
+                <a:cs typeface="Noto Sans CJK SC" pitchFamily="34" charset="-120"/>
+              </a:rPr>
+              <a:t>[comparison-gap] https://www.sec.gov/Archives/edgar/data/320193/000032019324000123/aapl-20240928.htm ; https://global.toyota/pages/global_toyota/ir/library/sec/20-F_202403_final.pdf ; https://global.toyota/pages/global_toyota/ir/library/sec/20-F_202403_final.pdf · PDF 32 ; PDF 167 ; PDF 167</a:t>
+            </a:r>
+            <a:endParaRPr lang="en-US" sz="800" dirty="0"/>
           </a:p>
         </p:txBody>
       </p:sp>
@@ -4839,7 +5011,7 @@
         </p:nvSpPr>
         <p:spPr>
           <a:xfrm>
-            <a:off x="822960" y="6355080"/>
+            <a:off x="822960" y="6053328"/>
             <a:ext cx="10424160" cy="228600"/>
           </a:xfrm>
           <a:prstGeom prst="rect">
@@ -4867,6 +5039,45 @@
               <a:t>参考稿；资料与专业结论待审阅</a:t>
             </a:r>
             <a:endParaRPr lang="en-US" sz="900" dirty="0"/>
+          </a:p>
+        </p:txBody>
+      </p:sp>
+      <p:sp>
+        <p:nvSpPr>
+          <p:cNvPr id="5" name="source-attribution"/>
+          <p:cNvSpPr/>
+          <p:nvPr/>
+        </p:nvSpPr>
+        <p:spPr>
+          <a:xfrm>
+            <a:off x="457200" y="6446520"/>
+            <a:ext cx="11247120" cy="274320"/>
+          </a:xfrm>
+          <a:prstGeom prst="rect">
+            <a:avLst/>
+          </a:prstGeom>
+          <a:noFill/>
+          <a:ln/>
+        </p:spPr>
+        <p:txBody>
+          <a:bodyPr wrap="square" lIns="0" tIns="0" rIns="0" bIns="0" rtlCol="0" anchor="t"/>
+          <a:lstStyle/>
+          <a:p>
+            <a:pPr algn="l" indent="0" marL="0">
+              <a:buNone/>
+            </a:pPr>
+            <a:r>
+              <a:rPr lang="en-US" sz="800" dirty="0">
+                <a:solidFill>
+                  <a:srgbClr val="173248"/>
+                </a:solidFill>
+                <a:latin typeface="Noto Sans CJK SC" pitchFamily="34" charset="0"/>
+                <a:ea typeface="Noto Sans CJK SC" pitchFamily="34" charset="-122"/>
+                <a:cs typeface="Noto Sans CJK SC" pitchFamily="34" charset="-120"/>
+              </a:rPr>
+              <a:t>[comparison-gap] https://www.sec.gov/Archives/edgar/data/320193/000032019324000123/aapl-20240928.htm ; https://global.toyota/pages/global_toyota/ir/library/sec/20-F_202403_final.pdf ; https://global.toyota/pages/global_toyota/ir/library/sec/20-F_202403_final.pdf · PDF 32 ; PDF 167 ; PDF 167</a:t>
+            </a:r>
+            <a:endParaRPr lang="en-US" sz="800" dirty="0"/>
           </a:p>
         </p:txBody>
       </p:sp>

</xml_diff>